<commit_message>
Add Budget Optimizer: spend reallocation charts + deck slide
- Dashboard: new full-width Budget Optimizer section in MMM tab
  - Side-by-side horizontal bar charts (current vs optimized allocation)
  - Channel action table with ROAS, spend changes, reduce/increase/hold tags
  - 3 KPI callouts: $970K reallocated, +$2.1M proj. revenue, ROAS 2.21×→2.35×
- Business deck: new Budget Optimizer slide (7 slides total)
  - Same reallocation table with color-coded changes
  - Green/red indicators on ROAS and change columns
</commit_message>
<xml_diff>
--- a/docs/CPG_Retail_Platform_Showcase.pptx
+++ b/docs/CPG_Retail_Platform_Showcase.pptx
@@ -11,6 +11,7 @@
     <p:sldId id="259" r:id="rId10"/>
     <p:sldId id="260" r:id="rId11"/>
     <p:sldId id="261" r:id="rId12"/>
+    <p:sldId id="262" r:id="rId13"/>
   </p:sldIdLst>
   <p:sldSz cx="12188952" cy="6858000" type="screen4x3"/>
   <p:notesSz cx="6858000" cy="9144000"/>
@@ -4326,6 +4327,339 @@
             <a:avLst/>
           </a:prstGeom>
           <a:solidFill>
+            <a:srgbClr val="27AE60"/>
+          </a:solidFill>
+          <a:ln>
+            <a:noFill/>
+          </a:ln>
+        </p:spPr>
+        <p:style>
+          <a:lnRef idx="1">
+            <a:schemeClr val="accent1"/>
+          </a:lnRef>
+          <a:fillRef idx="3">
+            <a:schemeClr val="accent1"/>
+          </a:fillRef>
+          <a:effectRef idx="2">
+            <a:schemeClr val="accent1"/>
+          </a:effectRef>
+          <a:fontRef idx="minor">
+            <a:schemeClr val="lt1"/>
+          </a:fontRef>
+        </p:style>
+        <p:txBody>
+          <a:bodyPr rtlCol="0" anchor="ctr"/>
+          <a:lstStyle/>
+          <a:p>
+            <a:pPr algn="ctr"/>
+          </a:p>
+        </p:txBody>
+      </p:sp>
+      <p:sp>
+        <p:nvSpPr>
+          <p:cNvPr id="3" name="TextBox 2"/>
+          <p:cNvSpPr txBox="1"/>
+          <p:nvPr/>
+        </p:nvSpPr>
+        <p:spPr>
+          <a:xfrm>
+            <a:off x="457200" y="182880"/>
+            <a:ext cx="10972800" cy="640080"/>
+          </a:xfrm>
+          <a:prstGeom prst="rect">
+            <a:avLst/>
+          </a:prstGeom>
+          <a:noFill/>
+        </p:spPr>
+        <p:txBody>
+          <a:bodyPr wrap="square">
+            <a:spAutoFit/>
+          </a:bodyPr>
+          <a:lstStyle/>
+          <a:p>
+            <a:pPr algn="l"/>
+            <a:r>
+              <a:rPr sz="2400" b="1">
+                <a:solidFill>
+                  <a:srgbClr val="FFFFFF"/>
+                </a:solidFill>
+              </a:rPr>
+              <a:t>Budget Optimizer — Same Spend, More Revenue</a:t>
+            </a:r>
+          </a:p>
+        </p:txBody>
+      </p:sp>
+      <p:sp>
+        <p:nvSpPr>
+          <p:cNvPr id="4" name="TextBox 3"/>
+          <p:cNvSpPr txBox="1"/>
+          <p:nvPr/>
+        </p:nvSpPr>
+        <p:spPr>
+          <a:xfrm>
+            <a:off x="548640" y="1097280"/>
+            <a:ext cx="10972800" cy="411480"/>
+          </a:xfrm>
+          <a:prstGeom prst="rect">
+            <a:avLst/>
+          </a:prstGeom>
+          <a:noFill/>
+        </p:spPr>
+        <p:txBody>
+          <a:bodyPr wrap="square">
+            <a:spAutoFit/>
+          </a:bodyPr>
+          <a:lstStyle/>
+          <a:p>
+            <a:pPr algn="l"/>
+            <a:r>
+              <a:rPr sz="1300" b="0">
+                <a:solidFill>
+                  <a:srgbClr val="6B7A90"/>
+                </a:solidFill>
+              </a:rPr>
+              <a:t>Shift $970K from low-ROAS channels into Email, Paid Search, and FB/IG. Total budget unchanged at $15.0M.</a:t>
+            </a:r>
+          </a:p>
+        </p:txBody>
+      </p:sp>
+      <p:sp>
+        <p:nvSpPr>
+          <p:cNvPr id="5" name="Rectangle 4"/>
+          <p:cNvSpPr/>
+          <p:nvPr/>
+        </p:nvSpPr>
+        <p:spPr>
+          <a:xfrm>
+            <a:off x="457200" y="1691640"/>
+            <a:ext cx="2560320" cy="1188720"/>
+          </a:xfrm>
+          <a:prstGeom prst="rect">
+            <a:avLst/>
+          </a:prstGeom>
+          <a:solidFill>
+            <a:srgbClr val="009B8E"/>
+          </a:solidFill>
+          <a:ln>
+            <a:noFill/>
+          </a:ln>
+        </p:spPr>
+        <p:style>
+          <a:lnRef idx="1">
+            <a:schemeClr val="accent1"/>
+          </a:lnRef>
+          <a:fillRef idx="3">
+            <a:schemeClr val="accent1"/>
+          </a:fillRef>
+          <a:effectRef idx="2">
+            <a:schemeClr val="accent1"/>
+          </a:effectRef>
+          <a:fontRef idx="minor">
+            <a:schemeClr val="lt1"/>
+          </a:fontRef>
+        </p:style>
+        <p:txBody>
+          <a:bodyPr rtlCol="0" anchor="ctr"/>
+          <a:lstStyle/>
+          <a:p>
+            <a:pPr algn="ctr"/>
+          </a:p>
+        </p:txBody>
+      </p:sp>
+      <p:sp>
+        <p:nvSpPr>
+          <p:cNvPr id="6" name="TextBox 5"/>
+          <p:cNvSpPr txBox="1"/>
+          <p:nvPr/>
+        </p:nvSpPr>
+        <p:spPr>
+          <a:xfrm>
+            <a:off x="548640" y="1783080"/>
+            <a:ext cx="2377440" cy="457200"/>
+          </a:xfrm>
+          <a:prstGeom prst="rect">
+            <a:avLst/>
+          </a:prstGeom>
+          <a:noFill/>
+        </p:spPr>
+        <p:txBody>
+          <a:bodyPr wrap="square">
+            <a:spAutoFit/>
+          </a:bodyPr>
+          <a:lstStyle/>
+          <a:p>
+            <a:pPr algn="ctr"/>
+            <a:r>
+              <a:rPr sz="2600" b="1">
+                <a:solidFill>
+                  <a:srgbClr val="FFFFFF"/>
+                </a:solidFill>
+              </a:rPr>
+              <a:t>$970K</a:t>
+            </a:r>
+          </a:p>
+        </p:txBody>
+      </p:sp>
+      <p:sp>
+        <p:nvSpPr>
+          <p:cNvPr id="7" name="TextBox 6"/>
+          <p:cNvSpPr txBox="1"/>
+          <p:nvPr/>
+        </p:nvSpPr>
+        <p:spPr>
+          <a:xfrm>
+            <a:off x="548640" y="2377440"/>
+            <a:ext cx="2377440" cy="365760"/>
+          </a:xfrm>
+          <a:prstGeom prst="rect">
+            <a:avLst/>
+          </a:prstGeom>
+          <a:noFill/>
+        </p:spPr>
+        <p:txBody>
+          <a:bodyPr wrap="square">
+            <a:spAutoFit/>
+          </a:bodyPr>
+          <a:lstStyle/>
+          <a:p>
+            <a:pPr algn="ctr"/>
+            <a:r>
+              <a:rPr sz="1100" b="0">
+                <a:solidFill>
+                  <a:srgbClr val="FFFFFF"/>
+                </a:solidFill>
+              </a:rPr>
+              <a:t>Reallocated</a:t>
+            </a:r>
+          </a:p>
+        </p:txBody>
+      </p:sp>
+      <p:sp>
+        <p:nvSpPr>
+          <p:cNvPr id="8" name="Rectangle 7"/>
+          <p:cNvSpPr/>
+          <p:nvPr/>
+        </p:nvSpPr>
+        <p:spPr>
+          <a:xfrm>
+            <a:off x="4297680" y="1691640"/>
+            <a:ext cx="2560320" cy="1188720"/>
+          </a:xfrm>
+          <a:prstGeom prst="rect">
+            <a:avLst/>
+          </a:prstGeom>
+          <a:solidFill>
+            <a:srgbClr val="27AE60"/>
+          </a:solidFill>
+          <a:ln>
+            <a:noFill/>
+          </a:ln>
+        </p:spPr>
+        <p:style>
+          <a:lnRef idx="1">
+            <a:schemeClr val="accent1"/>
+          </a:lnRef>
+          <a:fillRef idx="3">
+            <a:schemeClr val="accent1"/>
+          </a:fillRef>
+          <a:effectRef idx="2">
+            <a:schemeClr val="accent1"/>
+          </a:effectRef>
+          <a:fontRef idx="minor">
+            <a:schemeClr val="lt1"/>
+          </a:fontRef>
+        </p:style>
+        <p:txBody>
+          <a:bodyPr rtlCol="0" anchor="ctr"/>
+          <a:lstStyle/>
+          <a:p>
+            <a:pPr algn="ctr"/>
+          </a:p>
+        </p:txBody>
+      </p:sp>
+      <p:sp>
+        <p:nvSpPr>
+          <p:cNvPr id="9" name="TextBox 8"/>
+          <p:cNvSpPr txBox="1"/>
+          <p:nvPr/>
+        </p:nvSpPr>
+        <p:spPr>
+          <a:xfrm>
+            <a:off x="4389120" y="1783080"/>
+            <a:ext cx="2377440" cy="457200"/>
+          </a:xfrm>
+          <a:prstGeom prst="rect">
+            <a:avLst/>
+          </a:prstGeom>
+          <a:noFill/>
+        </p:spPr>
+        <p:txBody>
+          <a:bodyPr wrap="square">
+            <a:spAutoFit/>
+          </a:bodyPr>
+          <a:lstStyle/>
+          <a:p>
+            <a:pPr algn="ctr"/>
+            <a:r>
+              <a:rPr sz="2600" b="1">
+                <a:solidFill>
+                  <a:srgbClr val="FFFFFF"/>
+                </a:solidFill>
+              </a:rPr>
+              <a:t>+$2.1M</a:t>
+            </a:r>
+          </a:p>
+        </p:txBody>
+      </p:sp>
+      <p:sp>
+        <p:nvSpPr>
+          <p:cNvPr id="10" name="TextBox 9"/>
+          <p:cNvSpPr txBox="1"/>
+          <p:nvPr/>
+        </p:nvSpPr>
+        <p:spPr>
+          <a:xfrm>
+            <a:off x="4389120" y="2377440"/>
+            <a:ext cx="2377440" cy="365760"/>
+          </a:xfrm>
+          <a:prstGeom prst="rect">
+            <a:avLst/>
+          </a:prstGeom>
+          <a:noFill/>
+        </p:spPr>
+        <p:txBody>
+          <a:bodyPr wrap="square">
+            <a:spAutoFit/>
+          </a:bodyPr>
+          <a:lstStyle/>
+          <a:p>
+            <a:pPr algn="ctr"/>
+            <a:r>
+              <a:rPr sz="1100" b="0">
+                <a:solidFill>
+                  <a:srgbClr val="FFFFFF"/>
+                </a:solidFill>
+              </a:rPr>
+              <a:t>Proj. Revenue Gain</a:t>
+            </a:r>
+          </a:p>
+        </p:txBody>
+      </p:sp>
+      <p:sp>
+        <p:nvSpPr>
+          <p:cNvPr id="11" name="Rectangle 10"/>
+          <p:cNvSpPr/>
+          <p:nvPr/>
+        </p:nvSpPr>
+        <p:spPr>
+          <a:xfrm>
+            <a:off x="8138160" y="1691640"/>
+            <a:ext cx="2560320" cy="1188720"/>
+          </a:xfrm>
+          <a:prstGeom prst="rect">
+            <a:avLst/>
+          </a:prstGeom>
+          <a:solidFill>
             <a:srgbClr val="1A2E4A"/>
           </a:solidFill>
           <a:ln>
@@ -4356,253 +4690,2325 @@
       </p:sp>
       <p:sp>
         <p:nvSpPr>
-          <p:cNvPr id="3" name="TextBox 2"/>
-          <p:cNvSpPr txBox="1"/>
-          <p:nvPr/>
-        </p:nvSpPr>
-        <p:spPr>
-          <a:xfrm>
-            <a:off x="457200" y="182880"/>
-            <a:ext cx="10972800" cy="640080"/>
-          </a:xfrm>
-          <a:prstGeom prst="rect">
-            <a:avLst/>
-          </a:prstGeom>
-          <a:noFill/>
-        </p:spPr>
-        <p:txBody>
-          <a:bodyPr wrap="square">
-            <a:spAutoFit/>
-          </a:bodyPr>
-          <a:lstStyle/>
-          <a:p>
-            <a:pPr algn="l"/>
+          <p:cNvPr id="12" name="TextBox 11"/>
+          <p:cNvSpPr txBox="1"/>
+          <p:nvPr/>
+        </p:nvSpPr>
+        <p:spPr>
+          <a:xfrm>
+            <a:off x="8229600" y="1783080"/>
+            <a:ext cx="2377440" cy="457200"/>
+          </a:xfrm>
+          <a:prstGeom prst="rect">
+            <a:avLst/>
+          </a:prstGeom>
+          <a:noFill/>
+        </p:spPr>
+        <p:txBody>
+          <a:bodyPr wrap="square">
+            <a:spAutoFit/>
+          </a:bodyPr>
+          <a:lstStyle/>
+          <a:p>
+            <a:pPr algn="ctr"/>
             <a:r>
               <a:rPr sz="2600" b="1">
                 <a:solidFill>
                   <a:srgbClr val="FFFFFF"/>
                 </a:solidFill>
               </a:rPr>
-              <a:t>Sales &amp; Funnel Highlights</a:t>
-            </a:r>
-          </a:p>
-        </p:txBody>
-      </p:sp>
-      <p:sp>
-        <p:nvSpPr>
-          <p:cNvPr id="4" name="TextBox 3"/>
-          <p:cNvSpPr txBox="1"/>
-          <p:nvPr/>
-        </p:nvSpPr>
-        <p:spPr>
-          <a:xfrm>
-            <a:off x="731520" y="1280160"/>
-            <a:ext cx="10515600" cy="822960"/>
-          </a:xfrm>
-          <a:prstGeom prst="rect">
-            <a:avLst/>
-          </a:prstGeom>
-          <a:noFill/>
-        </p:spPr>
-        <p:txBody>
-          <a:bodyPr wrap="square">
-            <a:spAutoFit/>
-          </a:bodyPr>
-          <a:lstStyle/>
-          <a:p>
-            <a:pPr algn="l"/>
-            <a:r>
-              <a:rPr sz="1600" b="0">
+              <a:t>2.21×→2.35×</a:t>
+            </a:r>
+          </a:p>
+        </p:txBody>
+      </p:sp>
+      <p:sp>
+        <p:nvSpPr>
+          <p:cNvPr id="13" name="TextBox 12"/>
+          <p:cNvSpPr txBox="1"/>
+          <p:nvPr/>
+        </p:nvSpPr>
+        <p:spPr>
+          <a:xfrm>
+            <a:off x="8229600" y="2377440"/>
+            <a:ext cx="2377440" cy="365760"/>
+          </a:xfrm>
+          <a:prstGeom prst="rect">
+            <a:avLst/>
+          </a:prstGeom>
+          <a:noFill/>
+        </p:spPr>
+        <p:txBody>
+          <a:bodyPr wrap="square">
+            <a:spAutoFit/>
+          </a:bodyPr>
+          <a:lstStyle/>
+          <a:p>
+            <a:pPr algn="ctr"/>
+            <a:r>
+              <a:rPr sz="1100" b="0">
+                <a:solidFill>
+                  <a:srgbClr val="FFFFFF"/>
+                </a:solidFill>
+              </a:rPr>
+              <a:t>Blended ROAS</a:t>
+            </a:r>
+          </a:p>
+        </p:txBody>
+      </p:sp>
+      <p:sp>
+        <p:nvSpPr>
+          <p:cNvPr id="14" name="Rectangle 13"/>
+          <p:cNvSpPr/>
+          <p:nvPr/>
+        </p:nvSpPr>
+        <p:spPr>
+          <a:xfrm>
+            <a:off x="365760" y="3246120"/>
+            <a:ext cx="11430000" cy="292608"/>
+          </a:xfrm>
+          <a:prstGeom prst="rect">
+            <a:avLst/>
+          </a:prstGeom>
+          <a:solidFill>
+            <a:srgbClr val="1A2E4A"/>
+          </a:solidFill>
+          <a:ln>
+            <a:noFill/>
+          </a:ln>
+        </p:spPr>
+        <p:style>
+          <a:lnRef idx="1">
+            <a:schemeClr val="accent1"/>
+          </a:lnRef>
+          <a:fillRef idx="3">
+            <a:schemeClr val="accent1"/>
+          </a:fillRef>
+          <a:effectRef idx="2">
+            <a:schemeClr val="accent1"/>
+          </a:effectRef>
+          <a:fontRef idx="minor">
+            <a:schemeClr val="lt1"/>
+          </a:fontRef>
+        </p:style>
+        <p:txBody>
+          <a:bodyPr rtlCol="0" anchor="ctr"/>
+          <a:lstStyle/>
+          <a:p>
+            <a:pPr algn="ctr"/>
+          </a:p>
+        </p:txBody>
+      </p:sp>
+      <p:sp>
+        <p:nvSpPr>
+          <p:cNvPr id="15" name="TextBox 14"/>
+          <p:cNvSpPr txBox="1"/>
+          <p:nvPr/>
+        </p:nvSpPr>
+        <p:spPr>
+          <a:xfrm>
+            <a:off x="457200" y="3282696"/>
+            <a:ext cx="1554480" cy="256032"/>
+          </a:xfrm>
+          <a:prstGeom prst="rect">
+            <a:avLst/>
+          </a:prstGeom>
+          <a:noFill/>
+        </p:spPr>
+        <p:txBody>
+          <a:bodyPr wrap="square">
+            <a:spAutoFit/>
+          </a:bodyPr>
+          <a:lstStyle/>
+          <a:p>
+            <a:pPr algn="l"/>
+            <a:r>
+              <a:rPr sz="1000" b="1">
+                <a:solidFill>
+                  <a:srgbClr val="FFFFFF"/>
+                </a:solidFill>
+              </a:rPr>
+              <a:t>Channel</a:t>
+            </a:r>
+          </a:p>
+        </p:txBody>
+      </p:sp>
+      <p:sp>
+        <p:nvSpPr>
+          <p:cNvPr id="16" name="TextBox 15"/>
+          <p:cNvSpPr txBox="1"/>
+          <p:nvPr/>
+        </p:nvSpPr>
+        <p:spPr>
+          <a:xfrm>
+            <a:off x="2194560" y="3282696"/>
+            <a:ext cx="1097280" cy="256032"/>
+          </a:xfrm>
+          <a:prstGeom prst="rect">
+            <a:avLst/>
+          </a:prstGeom>
+          <a:noFill/>
+        </p:spPr>
+        <p:txBody>
+          <a:bodyPr wrap="square">
+            <a:spAutoFit/>
+          </a:bodyPr>
+          <a:lstStyle/>
+          <a:p>
+            <a:pPr algn="l"/>
+            <a:r>
+              <a:rPr sz="1000" b="1">
+                <a:solidFill>
+                  <a:srgbClr val="FFFFFF"/>
+                </a:solidFill>
+              </a:rPr>
+              <a:t>ROAS</a:t>
+            </a:r>
+          </a:p>
+        </p:txBody>
+      </p:sp>
+      <p:sp>
+        <p:nvSpPr>
+          <p:cNvPr id="17" name="TextBox 16"/>
+          <p:cNvSpPr txBox="1"/>
+          <p:nvPr/>
+        </p:nvSpPr>
+        <p:spPr>
+          <a:xfrm>
+            <a:off x="3474720" y="3282696"/>
+            <a:ext cx="1097280" cy="256032"/>
+          </a:xfrm>
+          <a:prstGeom prst="rect">
+            <a:avLst/>
+          </a:prstGeom>
+          <a:noFill/>
+        </p:spPr>
+        <p:txBody>
+          <a:bodyPr wrap="square">
+            <a:spAutoFit/>
+          </a:bodyPr>
+          <a:lstStyle/>
+          <a:p>
+            <a:pPr algn="l"/>
+            <a:r>
+              <a:rPr sz="1000" b="1">
+                <a:solidFill>
+                  <a:srgbClr val="FFFFFF"/>
+                </a:solidFill>
+              </a:rPr>
+              <a:t>Current</a:t>
+            </a:r>
+          </a:p>
+        </p:txBody>
+      </p:sp>
+      <p:sp>
+        <p:nvSpPr>
+          <p:cNvPr id="18" name="TextBox 17"/>
+          <p:cNvSpPr txBox="1"/>
+          <p:nvPr/>
+        </p:nvSpPr>
+        <p:spPr>
+          <a:xfrm>
+            <a:off x="4754880" y="3282696"/>
+            <a:ext cx="1097280" cy="256032"/>
+          </a:xfrm>
+          <a:prstGeom prst="rect">
+            <a:avLst/>
+          </a:prstGeom>
+          <a:noFill/>
+        </p:spPr>
+        <p:txBody>
+          <a:bodyPr wrap="square">
+            <a:spAutoFit/>
+          </a:bodyPr>
+          <a:lstStyle/>
+          <a:p>
+            <a:pPr algn="l"/>
+            <a:r>
+              <a:rPr sz="1000" b="1">
+                <a:solidFill>
+                  <a:srgbClr val="FFFFFF"/>
+                </a:solidFill>
+              </a:rPr>
+              <a:t>Optimized</a:t>
+            </a:r>
+          </a:p>
+        </p:txBody>
+      </p:sp>
+      <p:sp>
+        <p:nvSpPr>
+          <p:cNvPr id="19" name="TextBox 18"/>
+          <p:cNvSpPr txBox="1"/>
+          <p:nvPr/>
+        </p:nvSpPr>
+        <p:spPr>
+          <a:xfrm>
+            <a:off x="6035040" y="3282696"/>
+            <a:ext cx="1097280" cy="256032"/>
+          </a:xfrm>
+          <a:prstGeom prst="rect">
+            <a:avLst/>
+          </a:prstGeom>
+          <a:noFill/>
+        </p:spPr>
+        <p:txBody>
+          <a:bodyPr wrap="square">
+            <a:spAutoFit/>
+          </a:bodyPr>
+          <a:lstStyle/>
+          <a:p>
+            <a:pPr algn="l"/>
+            <a:r>
+              <a:rPr sz="1000" b="1">
+                <a:solidFill>
+                  <a:srgbClr val="FFFFFF"/>
+                </a:solidFill>
+              </a:rPr>
+              <a:t>Change</a:t>
+            </a:r>
+          </a:p>
+        </p:txBody>
+      </p:sp>
+      <p:sp>
+        <p:nvSpPr>
+          <p:cNvPr id="20" name="TextBox 19"/>
+          <p:cNvSpPr txBox="1"/>
+          <p:nvPr/>
+        </p:nvSpPr>
+        <p:spPr>
+          <a:xfrm>
+            <a:off x="7315200" y="3282696"/>
+            <a:ext cx="2286000" cy="256032"/>
+          </a:xfrm>
+          <a:prstGeom prst="rect">
+            <a:avLst/>
+          </a:prstGeom>
+          <a:noFill/>
+        </p:spPr>
+        <p:txBody>
+          <a:bodyPr wrap="square">
+            <a:spAutoFit/>
+          </a:bodyPr>
+          <a:lstStyle/>
+          <a:p>
+            <a:pPr algn="l"/>
+            <a:r>
+              <a:rPr sz="1000" b="1">
+                <a:solidFill>
+                  <a:srgbClr val="FFFFFF"/>
+                </a:solidFill>
+              </a:rPr>
+              <a:t>Action</a:t>
+            </a:r>
+          </a:p>
+        </p:txBody>
+      </p:sp>
+      <p:sp>
+        <p:nvSpPr>
+          <p:cNvPr id="21" name="Rectangle 20"/>
+          <p:cNvSpPr/>
+          <p:nvPr/>
+        </p:nvSpPr>
+        <p:spPr>
+          <a:xfrm>
+            <a:off x="365760" y="3557016"/>
+            <a:ext cx="11430000" cy="347472"/>
+          </a:xfrm>
+          <a:prstGeom prst="rect">
+            <a:avLst/>
+          </a:prstGeom>
+          <a:solidFill>
+            <a:srgbClr val="F4F7FB"/>
+          </a:solidFill>
+          <a:ln>
+            <a:noFill/>
+          </a:ln>
+        </p:spPr>
+        <p:style>
+          <a:lnRef idx="1">
+            <a:schemeClr val="accent1"/>
+          </a:lnRef>
+          <a:fillRef idx="3">
+            <a:schemeClr val="accent1"/>
+          </a:fillRef>
+          <a:effectRef idx="2">
+            <a:schemeClr val="accent1"/>
+          </a:effectRef>
+          <a:fontRef idx="minor">
+            <a:schemeClr val="lt1"/>
+          </a:fontRef>
+        </p:style>
+        <p:txBody>
+          <a:bodyPr rtlCol="0" anchor="ctr"/>
+          <a:lstStyle/>
+          <a:p>
+            <a:pPr algn="ctr"/>
+          </a:p>
+        </p:txBody>
+      </p:sp>
+      <p:sp>
+        <p:nvSpPr>
+          <p:cNvPr id="22" name="TextBox 21"/>
+          <p:cNvSpPr txBox="1"/>
+          <p:nvPr/>
+        </p:nvSpPr>
+        <p:spPr>
+          <a:xfrm>
+            <a:off x="457200" y="3593592"/>
+            <a:ext cx="1554480" cy="292608"/>
+          </a:xfrm>
+          <a:prstGeom prst="rect">
+            <a:avLst/>
+          </a:prstGeom>
+          <a:noFill/>
+        </p:spPr>
+        <p:txBody>
+          <a:bodyPr wrap="square">
+            <a:spAutoFit/>
+          </a:bodyPr>
+          <a:lstStyle/>
+          <a:p>
+            <a:pPr algn="l"/>
+            <a:r>
+              <a:rPr sz="1100" b="0">
                 <a:solidFill>
                   <a:srgbClr val="1A2E4A"/>
                 </a:solidFill>
               </a:rPr>
-              <a:t>A 2.62% win rate is critically low. Of 25,019 leads, only ~655 converted, generating $31.4M in closed-won pipeline at a $48K average deal value. While the deal size is healthy, the volume of wasted leads suggests the funnel is either attracting unqualified prospects or failing to nurture mid-funnel leads effectively. For context, B2C-adjacent CPG pipelines should target 5-8% conversion rates.</a:t>
-            </a:r>
-          </a:p>
-        </p:txBody>
-      </p:sp>
-      <p:sp>
-        <p:nvSpPr>
-          <p:cNvPr id="5" name="TextBox 4"/>
-          <p:cNvSpPr txBox="1"/>
-          <p:nvPr/>
-        </p:nvSpPr>
-        <p:spPr>
-          <a:xfrm>
-            <a:off x="731520" y="2286000"/>
-            <a:ext cx="3657600" cy="365760"/>
-          </a:xfrm>
-          <a:prstGeom prst="rect">
-            <a:avLst/>
-          </a:prstGeom>
-          <a:noFill/>
-        </p:spPr>
-        <p:txBody>
-          <a:bodyPr wrap="square">
-            <a:spAutoFit/>
-          </a:bodyPr>
-          <a:lstStyle/>
-          <a:p>
-            <a:pPr algn="l"/>
-            <a:r>
-              <a:rPr sz="1500" b="1">
+              <a:t>Email</a:t>
+            </a:r>
+          </a:p>
+        </p:txBody>
+      </p:sp>
+      <p:sp>
+        <p:nvSpPr>
+          <p:cNvPr id="23" name="TextBox 22"/>
+          <p:cNvSpPr txBox="1"/>
+          <p:nvPr/>
+        </p:nvSpPr>
+        <p:spPr>
+          <a:xfrm>
+            <a:off x="2194560" y="3593592"/>
+            <a:ext cx="1097280" cy="292608"/>
+          </a:xfrm>
+          <a:prstGeom prst="rect">
+            <a:avLst/>
+          </a:prstGeom>
+          <a:noFill/>
+        </p:spPr>
+        <p:txBody>
+          <a:bodyPr wrap="square">
+            <a:spAutoFit/>
+          </a:bodyPr>
+          <a:lstStyle/>
+          <a:p>
+            <a:pPr algn="l"/>
+            <a:r>
+              <a:rPr sz="1100" b="0">
+                <a:solidFill>
+                  <a:srgbClr val="27AE60"/>
+                </a:solidFill>
+              </a:rPr>
+              <a:t>6.39×</a:t>
+            </a:r>
+          </a:p>
+        </p:txBody>
+      </p:sp>
+      <p:sp>
+        <p:nvSpPr>
+          <p:cNvPr id="24" name="TextBox 23"/>
+          <p:cNvSpPr txBox="1"/>
+          <p:nvPr/>
+        </p:nvSpPr>
+        <p:spPr>
+          <a:xfrm>
+            <a:off x="3474720" y="3593592"/>
+            <a:ext cx="1097280" cy="292608"/>
+          </a:xfrm>
+          <a:prstGeom prst="rect">
+            <a:avLst/>
+          </a:prstGeom>
+          <a:noFill/>
+        </p:spPr>
+        <p:txBody>
+          <a:bodyPr wrap="square">
+            <a:spAutoFit/>
+          </a:bodyPr>
+          <a:lstStyle/>
+          <a:p>
+            <a:pPr algn="l"/>
+            <a:r>
+              <a:rPr sz="1100" b="0">
                 <a:solidFill>
                   <a:srgbClr val="1A2E4A"/>
                 </a:solidFill>
               </a:rPr>
-              <a:t>Lead Quality Notes</a:t>
-            </a:r>
-          </a:p>
-        </p:txBody>
-      </p:sp>
-      <p:sp>
-        <p:nvSpPr>
-          <p:cNvPr id="6" name="TextBox 5"/>
-          <p:cNvSpPr txBox="1"/>
-          <p:nvPr/>
-        </p:nvSpPr>
-        <p:spPr>
-          <a:xfrm>
-            <a:off x="731520" y="2743200"/>
-            <a:ext cx="4572000" cy="1371600"/>
-          </a:xfrm>
-          <a:prstGeom prst="rect">
-            <a:avLst/>
-          </a:prstGeom>
-          <a:noFill/>
-        </p:spPr>
-        <p:txBody>
-          <a:bodyPr wrap="square">
-            <a:spAutoFit/>
-          </a:bodyPr>
-          <a:lstStyle/>
-          <a:p>
-            <a:pPr algn="l"/>
-            <a:r>
-              <a:rPr sz="1400" b="0">
+              <a:t>$527K</a:t>
+            </a:r>
+          </a:p>
+        </p:txBody>
+      </p:sp>
+      <p:sp>
+        <p:nvSpPr>
+          <p:cNvPr id="25" name="TextBox 24"/>
+          <p:cNvSpPr txBox="1"/>
+          <p:nvPr/>
+        </p:nvSpPr>
+        <p:spPr>
+          <a:xfrm>
+            <a:off x="4754880" y="3593592"/>
+            <a:ext cx="1097280" cy="292608"/>
+          </a:xfrm>
+          <a:prstGeom prst="rect">
+            <a:avLst/>
+          </a:prstGeom>
+          <a:noFill/>
+        </p:spPr>
+        <p:txBody>
+          <a:bodyPr wrap="square">
+            <a:spAutoFit/>
+          </a:bodyPr>
+          <a:lstStyle/>
+          <a:p>
+            <a:pPr algn="l"/>
+            <a:r>
+              <a:rPr sz="1100" b="0">
+                <a:solidFill>
+                  <a:srgbClr val="1A2E4A"/>
+                </a:solidFill>
+              </a:rPr>
+              <a:t>$1,327K</a:t>
+            </a:r>
+          </a:p>
+        </p:txBody>
+      </p:sp>
+      <p:sp>
+        <p:nvSpPr>
+          <p:cNvPr id="26" name="TextBox 25"/>
+          <p:cNvSpPr txBox="1"/>
+          <p:nvPr/>
+        </p:nvSpPr>
+        <p:spPr>
+          <a:xfrm>
+            <a:off x="6035040" y="3593592"/>
+            <a:ext cx="1097280" cy="292608"/>
+          </a:xfrm>
+          <a:prstGeom prst="rect">
+            <a:avLst/>
+          </a:prstGeom>
+          <a:noFill/>
+        </p:spPr>
+        <p:txBody>
+          <a:bodyPr wrap="square">
+            <a:spAutoFit/>
+          </a:bodyPr>
+          <a:lstStyle/>
+          <a:p>
+            <a:pPr algn="l"/>
+            <a:r>
+              <a:rPr sz="1100" b="1">
+                <a:solidFill>
+                  <a:srgbClr val="27AE60"/>
+                </a:solidFill>
+              </a:rPr>
+              <a:t>+$800K</a:t>
+            </a:r>
+          </a:p>
+        </p:txBody>
+      </p:sp>
+      <p:sp>
+        <p:nvSpPr>
+          <p:cNvPr id="27" name="TextBox 26"/>
+          <p:cNvSpPr txBox="1"/>
+          <p:nvPr/>
+        </p:nvSpPr>
+        <p:spPr>
+          <a:xfrm>
+            <a:off x="7315200" y="3593592"/>
+            <a:ext cx="2286000" cy="292608"/>
+          </a:xfrm>
+          <a:prstGeom prst="rect">
+            <a:avLst/>
+          </a:prstGeom>
+          <a:noFill/>
+        </p:spPr>
+        <p:txBody>
+          <a:bodyPr wrap="square">
+            <a:spAutoFit/>
+          </a:bodyPr>
+          <a:lstStyle/>
+          <a:p>
+            <a:pPr algn="l"/>
+            <a:r>
+              <a:rPr sz="1100" b="0">
+                <a:solidFill>
+                  <a:srgbClr val="1A2E4A"/>
+                </a:solidFill>
+              </a:rPr>
+              <a:t>Scale 2.5×</a:t>
+            </a:r>
+          </a:p>
+        </p:txBody>
+      </p:sp>
+      <p:sp>
+        <p:nvSpPr>
+          <p:cNvPr id="28" name="Rectangle 27"/>
+          <p:cNvSpPr/>
+          <p:nvPr/>
+        </p:nvSpPr>
+        <p:spPr>
+          <a:xfrm>
+            <a:off x="365760" y="3922776"/>
+            <a:ext cx="11430000" cy="347472"/>
+          </a:xfrm>
+          <a:prstGeom prst="rect">
+            <a:avLst/>
+          </a:prstGeom>
+          <a:solidFill>
+            <a:srgbClr val="FFFFFF"/>
+          </a:solidFill>
+          <a:ln>
+            <a:noFill/>
+          </a:ln>
+        </p:spPr>
+        <p:style>
+          <a:lnRef idx="1">
+            <a:schemeClr val="accent1"/>
+          </a:lnRef>
+          <a:fillRef idx="3">
+            <a:schemeClr val="accent1"/>
+          </a:fillRef>
+          <a:effectRef idx="2">
+            <a:schemeClr val="accent1"/>
+          </a:effectRef>
+          <a:fontRef idx="minor">
+            <a:schemeClr val="lt1"/>
+          </a:fontRef>
+        </p:style>
+        <p:txBody>
+          <a:bodyPr rtlCol="0" anchor="ctr"/>
+          <a:lstStyle/>
+          <a:p>
+            <a:pPr algn="ctr"/>
+          </a:p>
+        </p:txBody>
+      </p:sp>
+      <p:sp>
+        <p:nvSpPr>
+          <p:cNvPr id="29" name="TextBox 28"/>
+          <p:cNvSpPr txBox="1"/>
+          <p:nvPr/>
+        </p:nvSpPr>
+        <p:spPr>
+          <a:xfrm>
+            <a:off x="457200" y="3959352"/>
+            <a:ext cx="1554480" cy="292608"/>
+          </a:xfrm>
+          <a:prstGeom prst="rect">
+            <a:avLst/>
+          </a:prstGeom>
+          <a:noFill/>
+        </p:spPr>
+        <p:txBody>
+          <a:bodyPr wrap="square">
+            <a:spAutoFit/>
+          </a:bodyPr>
+          <a:lstStyle/>
+          <a:p>
+            <a:pPr algn="l"/>
+            <a:r>
+              <a:rPr sz="1100" b="0">
+                <a:solidFill>
+                  <a:srgbClr val="1A2E4A"/>
+                </a:solidFill>
+              </a:rPr>
+              <a:t>Paid Search</a:t>
+            </a:r>
+          </a:p>
+        </p:txBody>
+      </p:sp>
+      <p:sp>
+        <p:nvSpPr>
+          <p:cNvPr id="30" name="TextBox 29"/>
+          <p:cNvSpPr txBox="1"/>
+          <p:nvPr/>
+        </p:nvSpPr>
+        <p:spPr>
+          <a:xfrm>
+            <a:off x="2194560" y="3959352"/>
+            <a:ext cx="1097280" cy="292608"/>
+          </a:xfrm>
+          <a:prstGeom prst="rect">
+            <a:avLst/>
+          </a:prstGeom>
+          <a:noFill/>
+        </p:spPr>
+        <p:txBody>
+          <a:bodyPr wrap="square">
+            <a:spAutoFit/>
+          </a:bodyPr>
+          <a:lstStyle/>
+          <a:p>
+            <a:pPr algn="l"/>
+            <a:r>
+              <a:rPr sz="1100" b="0">
+                <a:solidFill>
+                  <a:srgbClr val="27AE60"/>
+                </a:solidFill>
+              </a:rPr>
+              <a:t>2.53×</a:t>
+            </a:r>
+          </a:p>
+        </p:txBody>
+      </p:sp>
+      <p:sp>
+        <p:nvSpPr>
+          <p:cNvPr id="31" name="TextBox 30"/>
+          <p:cNvSpPr txBox="1"/>
+          <p:nvPr/>
+        </p:nvSpPr>
+        <p:spPr>
+          <a:xfrm>
+            <a:off x="3474720" y="3959352"/>
+            <a:ext cx="1097280" cy="292608"/>
+          </a:xfrm>
+          <a:prstGeom prst="rect">
+            <a:avLst/>
+          </a:prstGeom>
+          <a:noFill/>
+        </p:spPr>
+        <p:txBody>
+          <a:bodyPr wrap="square">
+            <a:spAutoFit/>
+          </a:bodyPr>
+          <a:lstStyle/>
+          <a:p>
+            <a:pPr algn="l"/>
+            <a:r>
+              <a:rPr sz="1100" b="0">
+                <a:solidFill>
+                  <a:srgbClr val="1A2E4A"/>
+                </a:solidFill>
+              </a:rPr>
+              <a:t>$2,105K</a:t>
+            </a:r>
+          </a:p>
+        </p:txBody>
+      </p:sp>
+      <p:sp>
+        <p:nvSpPr>
+          <p:cNvPr id="32" name="TextBox 31"/>
+          <p:cNvSpPr txBox="1"/>
+          <p:nvPr/>
+        </p:nvSpPr>
+        <p:spPr>
+          <a:xfrm>
+            <a:off x="4754880" y="3959352"/>
+            <a:ext cx="1097280" cy="292608"/>
+          </a:xfrm>
+          <a:prstGeom prst="rect">
+            <a:avLst/>
+          </a:prstGeom>
+          <a:noFill/>
+        </p:spPr>
+        <p:txBody>
+          <a:bodyPr wrap="square">
+            <a:spAutoFit/>
+          </a:bodyPr>
+          <a:lstStyle/>
+          <a:p>
+            <a:pPr algn="l"/>
+            <a:r>
+              <a:rPr sz="1100" b="0">
+                <a:solidFill>
+                  <a:srgbClr val="1A2E4A"/>
+                </a:solidFill>
+              </a:rPr>
+              <a:t>$2,205K</a:t>
+            </a:r>
+          </a:p>
+        </p:txBody>
+      </p:sp>
+      <p:sp>
+        <p:nvSpPr>
+          <p:cNvPr id="33" name="TextBox 32"/>
+          <p:cNvSpPr txBox="1"/>
+          <p:nvPr/>
+        </p:nvSpPr>
+        <p:spPr>
+          <a:xfrm>
+            <a:off x="6035040" y="3959352"/>
+            <a:ext cx="1097280" cy="292608"/>
+          </a:xfrm>
+          <a:prstGeom prst="rect">
+            <a:avLst/>
+          </a:prstGeom>
+          <a:noFill/>
+        </p:spPr>
+        <p:txBody>
+          <a:bodyPr wrap="square">
+            <a:spAutoFit/>
+          </a:bodyPr>
+          <a:lstStyle/>
+          <a:p>
+            <a:pPr algn="l"/>
+            <a:r>
+              <a:rPr sz="1100" b="1">
+                <a:solidFill>
+                  <a:srgbClr val="27AE60"/>
+                </a:solidFill>
+              </a:rPr>
+              <a:t>+$100K</a:t>
+            </a:r>
+          </a:p>
+        </p:txBody>
+      </p:sp>
+      <p:sp>
+        <p:nvSpPr>
+          <p:cNvPr id="34" name="TextBox 33"/>
+          <p:cNvSpPr txBox="1"/>
+          <p:nvPr/>
+        </p:nvSpPr>
+        <p:spPr>
+          <a:xfrm>
+            <a:off x="7315200" y="3959352"/>
+            <a:ext cx="2286000" cy="292608"/>
+          </a:xfrm>
+          <a:prstGeom prst="rect">
+            <a:avLst/>
+          </a:prstGeom>
+          <a:noFill/>
+        </p:spPr>
+        <p:txBody>
+          <a:bodyPr wrap="square">
+            <a:spAutoFit/>
+          </a:bodyPr>
+          <a:lstStyle/>
+          <a:p>
+            <a:pPr algn="l"/>
+            <a:r>
+              <a:rPr sz="1100" b="0">
+                <a:solidFill>
+                  <a:srgbClr val="1A2E4A"/>
+                </a:solidFill>
+              </a:rPr>
+              <a:t>Increase</a:t>
+            </a:r>
+          </a:p>
+        </p:txBody>
+      </p:sp>
+      <p:sp>
+        <p:nvSpPr>
+          <p:cNvPr id="35" name="Rectangle 34"/>
+          <p:cNvSpPr/>
+          <p:nvPr/>
+        </p:nvSpPr>
+        <p:spPr>
+          <a:xfrm>
+            <a:off x="365760" y="4288536"/>
+            <a:ext cx="11430000" cy="347472"/>
+          </a:xfrm>
+          <a:prstGeom prst="rect">
+            <a:avLst/>
+          </a:prstGeom>
+          <a:solidFill>
+            <a:srgbClr val="F4F7FB"/>
+          </a:solidFill>
+          <a:ln>
+            <a:noFill/>
+          </a:ln>
+        </p:spPr>
+        <p:style>
+          <a:lnRef idx="1">
+            <a:schemeClr val="accent1"/>
+          </a:lnRef>
+          <a:fillRef idx="3">
+            <a:schemeClr val="accent1"/>
+          </a:fillRef>
+          <a:effectRef idx="2">
+            <a:schemeClr val="accent1"/>
+          </a:effectRef>
+          <a:fontRef idx="minor">
+            <a:schemeClr val="lt1"/>
+          </a:fontRef>
+        </p:style>
+        <p:txBody>
+          <a:bodyPr rtlCol="0" anchor="ctr"/>
+          <a:lstStyle/>
+          <a:p>
+            <a:pPr algn="ctr"/>
+          </a:p>
+        </p:txBody>
+      </p:sp>
+      <p:sp>
+        <p:nvSpPr>
+          <p:cNvPr id="36" name="TextBox 35"/>
+          <p:cNvSpPr txBox="1"/>
+          <p:nvPr/>
+        </p:nvSpPr>
+        <p:spPr>
+          <a:xfrm>
+            <a:off x="457200" y="4325112"/>
+            <a:ext cx="1554480" cy="292608"/>
+          </a:xfrm>
+          <a:prstGeom prst="rect">
+            <a:avLst/>
+          </a:prstGeom>
+          <a:noFill/>
+        </p:spPr>
+        <p:txBody>
+          <a:bodyPr wrap="square">
+            <a:spAutoFit/>
+          </a:bodyPr>
+          <a:lstStyle/>
+          <a:p>
+            <a:pPr algn="l"/>
+            <a:r>
+              <a:rPr sz="1100" b="0">
+                <a:solidFill>
+                  <a:srgbClr val="1A2E4A"/>
+                </a:solidFill>
+              </a:rPr>
+              <a:t>FB / IG</a:t>
+            </a:r>
+          </a:p>
+        </p:txBody>
+      </p:sp>
+      <p:sp>
+        <p:nvSpPr>
+          <p:cNvPr id="37" name="TextBox 36"/>
+          <p:cNvSpPr txBox="1"/>
+          <p:nvPr/>
+        </p:nvSpPr>
+        <p:spPr>
+          <a:xfrm>
+            <a:off x="2194560" y="4325112"/>
+            <a:ext cx="1097280" cy="292608"/>
+          </a:xfrm>
+          <a:prstGeom prst="rect">
+            <a:avLst/>
+          </a:prstGeom>
+          <a:noFill/>
+        </p:spPr>
+        <p:txBody>
+          <a:bodyPr wrap="square">
+            <a:spAutoFit/>
+          </a:bodyPr>
+          <a:lstStyle/>
+          <a:p>
+            <a:pPr algn="l"/>
+            <a:r>
+              <a:rPr sz="1100" b="0">
+                <a:solidFill>
+                  <a:srgbClr val="27AE60"/>
+                </a:solidFill>
+              </a:rPr>
+              <a:t>2.60×</a:t>
+            </a:r>
+          </a:p>
+        </p:txBody>
+      </p:sp>
+      <p:sp>
+        <p:nvSpPr>
+          <p:cNvPr id="38" name="TextBox 37"/>
+          <p:cNvSpPr txBox="1"/>
+          <p:nvPr/>
+        </p:nvSpPr>
+        <p:spPr>
+          <a:xfrm>
+            <a:off x="3474720" y="4325112"/>
+            <a:ext cx="1097280" cy="292608"/>
+          </a:xfrm>
+          <a:prstGeom prst="rect">
+            <a:avLst/>
+          </a:prstGeom>
+          <a:noFill/>
+        </p:spPr>
+        <p:txBody>
+          <a:bodyPr wrap="square">
+            <a:spAutoFit/>
+          </a:bodyPr>
+          <a:lstStyle/>
+          <a:p>
+            <a:pPr algn="l"/>
+            <a:r>
+              <a:rPr sz="1100" b="0">
+                <a:solidFill>
+                  <a:srgbClr val="1A2E4A"/>
+                </a:solidFill>
+              </a:rPr>
+              <a:t>$1,654K</a:t>
+            </a:r>
+          </a:p>
+        </p:txBody>
+      </p:sp>
+      <p:sp>
+        <p:nvSpPr>
+          <p:cNvPr id="39" name="TextBox 38"/>
+          <p:cNvSpPr txBox="1"/>
+          <p:nvPr/>
+        </p:nvSpPr>
+        <p:spPr>
+          <a:xfrm>
+            <a:off x="4754880" y="4325112"/>
+            <a:ext cx="1097280" cy="292608"/>
+          </a:xfrm>
+          <a:prstGeom prst="rect">
+            <a:avLst/>
+          </a:prstGeom>
+          <a:noFill/>
+        </p:spPr>
+        <p:txBody>
+          <a:bodyPr wrap="square">
+            <a:spAutoFit/>
+          </a:bodyPr>
+          <a:lstStyle/>
+          <a:p>
+            <a:pPr algn="l"/>
+            <a:r>
+              <a:rPr sz="1100" b="0">
+                <a:solidFill>
+                  <a:srgbClr val="1A2E4A"/>
+                </a:solidFill>
+              </a:rPr>
+              <a:t>$1,724K</a:t>
+            </a:r>
+          </a:p>
+        </p:txBody>
+      </p:sp>
+      <p:sp>
+        <p:nvSpPr>
+          <p:cNvPr id="40" name="TextBox 39"/>
+          <p:cNvSpPr txBox="1"/>
+          <p:nvPr/>
+        </p:nvSpPr>
+        <p:spPr>
+          <a:xfrm>
+            <a:off x="6035040" y="4325112"/>
+            <a:ext cx="1097280" cy="292608"/>
+          </a:xfrm>
+          <a:prstGeom prst="rect">
+            <a:avLst/>
+          </a:prstGeom>
+          <a:noFill/>
+        </p:spPr>
+        <p:txBody>
+          <a:bodyPr wrap="square">
+            <a:spAutoFit/>
+          </a:bodyPr>
+          <a:lstStyle/>
+          <a:p>
+            <a:pPr algn="l"/>
+            <a:r>
+              <a:rPr sz="1100" b="1">
+                <a:solidFill>
+                  <a:srgbClr val="27AE60"/>
+                </a:solidFill>
+              </a:rPr>
+              <a:t>+$70K</a:t>
+            </a:r>
+          </a:p>
+        </p:txBody>
+      </p:sp>
+      <p:sp>
+        <p:nvSpPr>
+          <p:cNvPr id="41" name="TextBox 40"/>
+          <p:cNvSpPr txBox="1"/>
+          <p:nvPr/>
+        </p:nvSpPr>
+        <p:spPr>
+          <a:xfrm>
+            <a:off x="7315200" y="4325112"/>
+            <a:ext cx="2286000" cy="292608"/>
+          </a:xfrm>
+          <a:prstGeom prst="rect">
+            <a:avLst/>
+          </a:prstGeom>
+          <a:noFill/>
+        </p:spPr>
+        <p:txBody>
+          <a:bodyPr wrap="square">
+            <a:spAutoFit/>
+          </a:bodyPr>
+          <a:lstStyle/>
+          <a:p>
+            <a:pPr algn="l"/>
+            <a:r>
+              <a:rPr sz="1100" b="0">
+                <a:solidFill>
+                  <a:srgbClr val="1A2E4A"/>
+                </a:solidFill>
+              </a:rPr>
+              <a:t>Increase</a:t>
+            </a:r>
+          </a:p>
+        </p:txBody>
+      </p:sp>
+      <p:sp>
+        <p:nvSpPr>
+          <p:cNvPr id="42" name="Rectangle 41"/>
+          <p:cNvSpPr/>
+          <p:nvPr/>
+        </p:nvSpPr>
+        <p:spPr>
+          <a:xfrm>
+            <a:off x="365760" y="4654296"/>
+            <a:ext cx="11430000" cy="347472"/>
+          </a:xfrm>
+          <a:prstGeom prst="rect">
+            <a:avLst/>
+          </a:prstGeom>
+          <a:solidFill>
+            <a:srgbClr val="FFFFFF"/>
+          </a:solidFill>
+          <a:ln>
+            <a:noFill/>
+          </a:ln>
+        </p:spPr>
+        <p:style>
+          <a:lnRef idx="1">
+            <a:schemeClr val="accent1"/>
+          </a:lnRef>
+          <a:fillRef idx="3">
+            <a:schemeClr val="accent1"/>
+          </a:fillRef>
+          <a:effectRef idx="2">
+            <a:schemeClr val="accent1"/>
+          </a:effectRef>
+          <a:fontRef idx="minor">
+            <a:schemeClr val="lt1"/>
+          </a:fontRef>
+        </p:style>
+        <p:txBody>
+          <a:bodyPr rtlCol="0" anchor="ctr"/>
+          <a:lstStyle/>
+          <a:p>
+            <a:pPr algn="ctr"/>
+          </a:p>
+        </p:txBody>
+      </p:sp>
+      <p:sp>
+        <p:nvSpPr>
+          <p:cNvPr id="43" name="TextBox 42"/>
+          <p:cNvSpPr txBox="1"/>
+          <p:nvPr/>
+        </p:nvSpPr>
+        <p:spPr>
+          <a:xfrm>
+            <a:off x="457200" y="4690872"/>
+            <a:ext cx="1554480" cy="292608"/>
+          </a:xfrm>
+          <a:prstGeom prst="rect">
+            <a:avLst/>
+          </a:prstGeom>
+          <a:noFill/>
+        </p:spPr>
+        <p:txBody>
+          <a:bodyPr wrap="square">
+            <a:spAutoFit/>
+          </a:bodyPr>
+          <a:lstStyle/>
+          <a:p>
+            <a:pPr algn="l"/>
+            <a:r>
+              <a:rPr sz="1100" b="0">
+                <a:solidFill>
+                  <a:srgbClr val="1A2E4A"/>
+                </a:solidFill>
+              </a:rPr>
+              <a:t>TV/CTV</a:t>
+            </a:r>
+          </a:p>
+        </p:txBody>
+      </p:sp>
+      <p:sp>
+        <p:nvSpPr>
+          <p:cNvPr id="44" name="TextBox 43"/>
+          <p:cNvSpPr txBox="1"/>
+          <p:nvPr/>
+        </p:nvSpPr>
+        <p:spPr>
+          <a:xfrm>
+            <a:off x="2194560" y="4690872"/>
+            <a:ext cx="1097280" cy="292608"/>
+          </a:xfrm>
+          <a:prstGeom prst="rect">
+            <a:avLst/>
+          </a:prstGeom>
+          <a:noFill/>
+        </p:spPr>
+        <p:txBody>
+          <a:bodyPr wrap="square">
+            <a:spAutoFit/>
+          </a:bodyPr>
+          <a:lstStyle/>
+          <a:p>
+            <a:pPr algn="l"/>
+            <a:r>
+              <a:rPr sz="1100" b="0">
+                <a:solidFill>
+                  <a:srgbClr val="E67E22"/>
+                </a:solidFill>
+              </a:rPr>
+              <a:t>2.34×</a:t>
+            </a:r>
+          </a:p>
+        </p:txBody>
+      </p:sp>
+      <p:sp>
+        <p:nvSpPr>
+          <p:cNvPr id="45" name="TextBox 44"/>
+          <p:cNvSpPr txBox="1"/>
+          <p:nvPr/>
+        </p:nvSpPr>
+        <p:spPr>
+          <a:xfrm>
+            <a:off x="3474720" y="4690872"/>
+            <a:ext cx="1097280" cy="292608"/>
+          </a:xfrm>
+          <a:prstGeom prst="rect">
+            <a:avLst/>
+          </a:prstGeom>
+          <a:noFill/>
+        </p:spPr>
+        <p:txBody>
+          <a:bodyPr wrap="square">
+            <a:spAutoFit/>
+          </a:bodyPr>
+          <a:lstStyle/>
+          <a:p>
+            <a:pPr algn="l"/>
+            <a:r>
+              <a:rPr sz="1100" b="0">
+                <a:solidFill>
+                  <a:srgbClr val="1A2E4A"/>
+                </a:solidFill>
+              </a:rPr>
+              <a:t>$5,606K</a:t>
+            </a:r>
+          </a:p>
+        </p:txBody>
+      </p:sp>
+      <p:sp>
+        <p:nvSpPr>
+          <p:cNvPr id="46" name="TextBox 45"/>
+          <p:cNvSpPr txBox="1"/>
+          <p:nvPr/>
+        </p:nvSpPr>
+        <p:spPr>
+          <a:xfrm>
+            <a:off x="4754880" y="4690872"/>
+            <a:ext cx="1097280" cy="292608"/>
+          </a:xfrm>
+          <a:prstGeom prst="rect">
+            <a:avLst/>
+          </a:prstGeom>
+          <a:noFill/>
+        </p:spPr>
+        <p:txBody>
+          <a:bodyPr wrap="square">
+            <a:spAutoFit/>
+          </a:bodyPr>
+          <a:lstStyle/>
+          <a:p>
+            <a:pPr algn="l"/>
+            <a:r>
+              <a:rPr sz="1100" b="0">
+                <a:solidFill>
+                  <a:srgbClr val="1A2E4A"/>
+                </a:solidFill>
+              </a:rPr>
+              <a:t>$5,606K</a:t>
+            </a:r>
+          </a:p>
+        </p:txBody>
+      </p:sp>
+      <p:sp>
+        <p:nvSpPr>
+          <p:cNvPr id="47" name="TextBox 46"/>
+          <p:cNvSpPr txBox="1"/>
+          <p:nvPr/>
+        </p:nvSpPr>
+        <p:spPr>
+          <a:xfrm>
+            <a:off x="6035040" y="4690872"/>
+            <a:ext cx="1097280" cy="292608"/>
+          </a:xfrm>
+          <a:prstGeom prst="rect">
+            <a:avLst/>
+          </a:prstGeom>
+          <a:noFill/>
+        </p:spPr>
+        <p:txBody>
+          <a:bodyPr wrap="square">
+            <a:spAutoFit/>
+          </a:bodyPr>
+          <a:lstStyle/>
+          <a:p>
+            <a:pPr algn="l"/>
+            <a:r>
+              <a:rPr sz="1100" b="0">
+                <a:solidFill>
+                  <a:srgbClr val="1A2E4A"/>
+                </a:solidFill>
+              </a:rPr>
+              <a:t>—</a:t>
+            </a:r>
+          </a:p>
+        </p:txBody>
+      </p:sp>
+      <p:sp>
+        <p:nvSpPr>
+          <p:cNvPr id="48" name="TextBox 47"/>
+          <p:cNvSpPr txBox="1"/>
+          <p:nvPr/>
+        </p:nvSpPr>
+        <p:spPr>
+          <a:xfrm>
+            <a:off x="7315200" y="4690872"/>
+            <a:ext cx="2286000" cy="292608"/>
+          </a:xfrm>
+          <a:prstGeom prst="rect">
+            <a:avLst/>
+          </a:prstGeom>
+          <a:noFill/>
+        </p:spPr>
+        <p:txBody>
+          <a:bodyPr wrap="square">
+            <a:spAutoFit/>
+          </a:bodyPr>
+          <a:lstStyle/>
+          <a:p>
+            <a:pPr algn="l"/>
+            <a:r>
+              <a:rPr sz="1100" b="0">
+                <a:solidFill>
+                  <a:srgbClr val="1A2E4A"/>
+                </a:solidFill>
+              </a:rPr>
+              <a:t>Hold (brand)</a:t>
+            </a:r>
+          </a:p>
+        </p:txBody>
+      </p:sp>
+      <p:sp>
+        <p:nvSpPr>
+          <p:cNvPr id="49" name="Rectangle 48"/>
+          <p:cNvSpPr/>
+          <p:nvPr/>
+        </p:nvSpPr>
+        <p:spPr>
+          <a:xfrm>
+            <a:off x="365760" y="5020056"/>
+            <a:ext cx="11430000" cy="347472"/>
+          </a:xfrm>
+          <a:prstGeom prst="rect">
+            <a:avLst/>
+          </a:prstGeom>
+          <a:solidFill>
+            <a:srgbClr val="F4F7FB"/>
+          </a:solidFill>
+          <a:ln>
+            <a:noFill/>
+          </a:ln>
+        </p:spPr>
+        <p:style>
+          <a:lnRef idx="1">
+            <a:schemeClr val="accent1"/>
+          </a:lnRef>
+          <a:fillRef idx="3">
+            <a:schemeClr val="accent1"/>
+          </a:fillRef>
+          <a:effectRef idx="2">
+            <a:schemeClr val="accent1"/>
+          </a:effectRef>
+          <a:fontRef idx="minor">
+            <a:schemeClr val="lt1"/>
+          </a:fontRef>
+        </p:style>
+        <p:txBody>
+          <a:bodyPr rtlCol="0" anchor="ctr"/>
+          <a:lstStyle/>
+          <a:p>
+            <a:pPr algn="ctr"/>
+          </a:p>
+        </p:txBody>
+      </p:sp>
+      <p:sp>
+        <p:nvSpPr>
+          <p:cNvPr id="50" name="TextBox 49"/>
+          <p:cNvSpPr txBox="1"/>
+          <p:nvPr/>
+        </p:nvSpPr>
+        <p:spPr>
+          <a:xfrm>
+            <a:off x="457200" y="5056632"/>
+            <a:ext cx="1554480" cy="292608"/>
+          </a:xfrm>
+          <a:prstGeom prst="rect">
+            <a:avLst/>
+          </a:prstGeom>
+          <a:noFill/>
+        </p:spPr>
+        <p:txBody>
+          <a:bodyPr wrap="square">
+            <a:spAutoFit/>
+          </a:bodyPr>
+          <a:lstStyle/>
+          <a:p>
+            <a:pPr algn="l"/>
+            <a:r>
+              <a:rPr sz="1100" b="0">
+                <a:solidFill>
+                  <a:srgbClr val="1A2E4A"/>
+                </a:solidFill>
+              </a:rPr>
+              <a:t>Influencer</a:t>
+            </a:r>
+          </a:p>
+        </p:txBody>
+      </p:sp>
+      <p:sp>
+        <p:nvSpPr>
+          <p:cNvPr id="51" name="TextBox 50"/>
+          <p:cNvSpPr txBox="1"/>
+          <p:nvPr/>
+        </p:nvSpPr>
+        <p:spPr>
+          <a:xfrm>
+            <a:off x="2194560" y="5056632"/>
+            <a:ext cx="1097280" cy="292608"/>
+          </a:xfrm>
+          <a:prstGeom prst="rect">
+            <a:avLst/>
+          </a:prstGeom>
+          <a:noFill/>
+        </p:spPr>
+        <p:txBody>
+          <a:bodyPr wrap="square">
+            <a:spAutoFit/>
+          </a:bodyPr>
+          <a:lstStyle/>
+          <a:p>
+            <a:pPr algn="l"/>
+            <a:r>
+              <a:rPr sz="1100" b="0">
+                <a:solidFill>
+                  <a:srgbClr val="E67E22"/>
+                </a:solidFill>
+              </a:rPr>
+              <a:t>2.29×</a:t>
+            </a:r>
+          </a:p>
+        </p:txBody>
+      </p:sp>
+      <p:sp>
+        <p:nvSpPr>
+          <p:cNvPr id="52" name="TextBox 51"/>
+          <p:cNvSpPr txBox="1"/>
+          <p:nvPr/>
+        </p:nvSpPr>
+        <p:spPr>
+          <a:xfrm>
+            <a:off x="3474720" y="5056632"/>
+            <a:ext cx="1097280" cy="292608"/>
+          </a:xfrm>
+          <a:prstGeom prst="rect">
+            <a:avLst/>
+          </a:prstGeom>
+          <a:noFill/>
+        </p:spPr>
+        <p:txBody>
+          <a:bodyPr wrap="square">
+            <a:spAutoFit/>
+          </a:bodyPr>
+          <a:lstStyle/>
+          <a:p>
+            <a:pPr algn="l"/>
+            <a:r>
+              <a:rPr sz="1100" b="0">
+                <a:solidFill>
+                  <a:srgbClr val="1A2E4A"/>
+                </a:solidFill>
+              </a:rPr>
+              <a:t>$1,854K</a:t>
+            </a:r>
+          </a:p>
+        </p:txBody>
+      </p:sp>
+      <p:sp>
+        <p:nvSpPr>
+          <p:cNvPr id="53" name="TextBox 52"/>
+          <p:cNvSpPr txBox="1"/>
+          <p:nvPr/>
+        </p:nvSpPr>
+        <p:spPr>
+          <a:xfrm>
+            <a:off x="4754880" y="5056632"/>
+            <a:ext cx="1097280" cy="292608"/>
+          </a:xfrm>
+          <a:prstGeom prst="rect">
+            <a:avLst/>
+          </a:prstGeom>
+          <a:noFill/>
+        </p:spPr>
+        <p:txBody>
+          <a:bodyPr wrap="square">
+            <a:spAutoFit/>
+          </a:bodyPr>
+          <a:lstStyle/>
+          <a:p>
+            <a:pPr algn="l"/>
+            <a:r>
+              <a:rPr sz="1100" b="0">
+                <a:solidFill>
+                  <a:srgbClr val="1A2E4A"/>
+                </a:solidFill>
+              </a:rPr>
+              <a:t>$1,854K</a:t>
+            </a:r>
+          </a:p>
+        </p:txBody>
+      </p:sp>
+      <p:sp>
+        <p:nvSpPr>
+          <p:cNvPr id="54" name="TextBox 53"/>
+          <p:cNvSpPr txBox="1"/>
+          <p:nvPr/>
+        </p:nvSpPr>
+        <p:spPr>
+          <a:xfrm>
+            <a:off x="6035040" y="5056632"/>
+            <a:ext cx="1097280" cy="292608"/>
+          </a:xfrm>
+          <a:prstGeom prst="rect">
+            <a:avLst/>
+          </a:prstGeom>
+          <a:noFill/>
+        </p:spPr>
+        <p:txBody>
+          <a:bodyPr wrap="square">
+            <a:spAutoFit/>
+          </a:bodyPr>
+          <a:lstStyle/>
+          <a:p>
+            <a:pPr algn="l"/>
+            <a:r>
+              <a:rPr sz="1100" b="0">
+                <a:solidFill>
+                  <a:srgbClr val="1A2E4A"/>
+                </a:solidFill>
+              </a:rPr>
+              <a:t>—</a:t>
+            </a:r>
+          </a:p>
+        </p:txBody>
+      </p:sp>
+      <p:sp>
+        <p:nvSpPr>
+          <p:cNvPr id="55" name="TextBox 54"/>
+          <p:cNvSpPr txBox="1"/>
+          <p:nvPr/>
+        </p:nvSpPr>
+        <p:spPr>
+          <a:xfrm>
+            <a:off x="7315200" y="5056632"/>
+            <a:ext cx="2286000" cy="292608"/>
+          </a:xfrm>
+          <a:prstGeom prst="rect">
+            <a:avLst/>
+          </a:prstGeom>
+          <a:noFill/>
+        </p:spPr>
+        <p:txBody>
+          <a:bodyPr wrap="square">
+            <a:spAutoFit/>
+          </a:bodyPr>
+          <a:lstStyle/>
+          <a:p>
+            <a:pPr algn="l"/>
+            <a:r>
+              <a:rPr sz="1100" b="0">
+                <a:solidFill>
+                  <a:srgbClr val="1A2E4A"/>
+                </a:solidFill>
+              </a:rPr>
+              <a:t>Hold</a:t>
+            </a:r>
+          </a:p>
+        </p:txBody>
+      </p:sp>
+      <p:sp>
+        <p:nvSpPr>
+          <p:cNvPr id="56" name="Rectangle 55"/>
+          <p:cNvSpPr/>
+          <p:nvPr/>
+        </p:nvSpPr>
+        <p:spPr>
+          <a:xfrm>
+            <a:off x="365760" y="5385816"/>
+            <a:ext cx="11430000" cy="347472"/>
+          </a:xfrm>
+          <a:prstGeom prst="rect">
+            <a:avLst/>
+          </a:prstGeom>
+          <a:solidFill>
+            <a:srgbClr val="FFFFFF"/>
+          </a:solidFill>
+          <a:ln>
+            <a:noFill/>
+          </a:ln>
+        </p:spPr>
+        <p:style>
+          <a:lnRef idx="1">
+            <a:schemeClr val="accent1"/>
+          </a:lnRef>
+          <a:fillRef idx="3">
+            <a:schemeClr val="accent1"/>
+          </a:fillRef>
+          <a:effectRef idx="2">
+            <a:schemeClr val="accent1"/>
+          </a:effectRef>
+          <a:fontRef idx="minor">
+            <a:schemeClr val="lt1"/>
+          </a:fontRef>
+        </p:style>
+        <p:txBody>
+          <a:bodyPr rtlCol="0" anchor="ctr"/>
+          <a:lstStyle/>
+          <a:p>
+            <a:pPr algn="ctr"/>
+          </a:p>
+        </p:txBody>
+      </p:sp>
+      <p:sp>
+        <p:nvSpPr>
+          <p:cNvPr id="57" name="TextBox 56"/>
+          <p:cNvSpPr txBox="1"/>
+          <p:nvPr/>
+        </p:nvSpPr>
+        <p:spPr>
+          <a:xfrm>
+            <a:off x="457200" y="5422392"/>
+            <a:ext cx="1554480" cy="292608"/>
+          </a:xfrm>
+          <a:prstGeom prst="rect">
+            <a:avLst/>
+          </a:prstGeom>
+          <a:noFill/>
+        </p:spPr>
+        <p:txBody>
+          <a:bodyPr wrap="square">
+            <a:spAutoFit/>
+          </a:bodyPr>
+          <a:lstStyle/>
+          <a:p>
+            <a:pPr algn="l"/>
+            <a:r>
+              <a:rPr sz="1100" b="0">
+                <a:solidFill>
+                  <a:srgbClr val="1A2E4A"/>
+                </a:solidFill>
+              </a:rPr>
+              <a:t>TikTok</a:t>
+            </a:r>
+          </a:p>
+        </p:txBody>
+      </p:sp>
+      <p:sp>
+        <p:nvSpPr>
+          <p:cNvPr id="58" name="TextBox 57"/>
+          <p:cNvSpPr txBox="1"/>
+          <p:nvPr/>
+        </p:nvSpPr>
+        <p:spPr>
+          <a:xfrm>
+            <a:off x="2194560" y="5422392"/>
+            <a:ext cx="1097280" cy="292608"/>
+          </a:xfrm>
+          <a:prstGeom prst="rect">
+            <a:avLst/>
+          </a:prstGeom>
+          <a:noFill/>
+        </p:spPr>
+        <p:txBody>
+          <a:bodyPr wrap="square">
+            <a:spAutoFit/>
+          </a:bodyPr>
+          <a:lstStyle/>
+          <a:p>
+            <a:pPr algn="l"/>
+            <a:r>
+              <a:rPr sz="1100" b="0">
+                <a:solidFill>
+                  <a:srgbClr val="C0392B"/>
+                </a:solidFill>
+              </a:rPr>
+              <a:t>1.83×</a:t>
+            </a:r>
+          </a:p>
+        </p:txBody>
+      </p:sp>
+      <p:sp>
+        <p:nvSpPr>
+          <p:cNvPr id="59" name="TextBox 58"/>
+          <p:cNvSpPr txBox="1"/>
+          <p:nvPr/>
+        </p:nvSpPr>
+        <p:spPr>
+          <a:xfrm>
+            <a:off x="3474720" y="5422392"/>
+            <a:ext cx="1097280" cy="292608"/>
+          </a:xfrm>
+          <a:prstGeom prst="rect">
+            <a:avLst/>
+          </a:prstGeom>
+          <a:noFill/>
+        </p:spPr>
+        <p:txBody>
+          <a:bodyPr wrap="square">
+            <a:spAutoFit/>
+          </a:bodyPr>
+          <a:lstStyle/>
+          <a:p>
+            <a:pPr algn="l"/>
+            <a:r>
+              <a:rPr sz="1100" b="0">
+                <a:solidFill>
+                  <a:srgbClr val="1A2E4A"/>
+                </a:solidFill>
+              </a:rPr>
+              <a:t>$1,209K</a:t>
+            </a:r>
+          </a:p>
+        </p:txBody>
+      </p:sp>
+      <p:sp>
+        <p:nvSpPr>
+          <p:cNvPr id="60" name="TextBox 59"/>
+          <p:cNvSpPr txBox="1"/>
+          <p:nvPr/>
+        </p:nvSpPr>
+        <p:spPr>
+          <a:xfrm>
+            <a:off x="4754880" y="5422392"/>
+            <a:ext cx="1097280" cy="292608"/>
+          </a:xfrm>
+          <a:prstGeom prst="rect">
+            <a:avLst/>
+          </a:prstGeom>
+          <a:noFill/>
+        </p:spPr>
+        <p:txBody>
+          <a:bodyPr wrap="square">
+            <a:spAutoFit/>
+          </a:bodyPr>
+          <a:lstStyle/>
+          <a:p>
+            <a:pPr algn="l"/>
+            <a:r>
+              <a:rPr sz="1100" b="0">
+                <a:solidFill>
+                  <a:srgbClr val="1A2E4A"/>
+                </a:solidFill>
+              </a:rPr>
+              <a:t>$846K</a:t>
+            </a:r>
+          </a:p>
+        </p:txBody>
+      </p:sp>
+      <p:sp>
+        <p:nvSpPr>
+          <p:cNvPr id="61" name="TextBox 60"/>
+          <p:cNvSpPr txBox="1"/>
+          <p:nvPr/>
+        </p:nvSpPr>
+        <p:spPr>
+          <a:xfrm>
+            <a:off x="6035040" y="5422392"/>
+            <a:ext cx="1097280" cy="292608"/>
+          </a:xfrm>
+          <a:prstGeom prst="rect">
+            <a:avLst/>
+          </a:prstGeom>
+          <a:noFill/>
+        </p:spPr>
+        <p:txBody>
+          <a:bodyPr wrap="square">
+            <a:spAutoFit/>
+          </a:bodyPr>
+          <a:lstStyle/>
+          <a:p>
+            <a:pPr algn="l"/>
+            <a:r>
+              <a:rPr sz="1100" b="1">
+                <a:solidFill>
+                  <a:srgbClr val="C0392B"/>
+                </a:solidFill>
+              </a:rPr>
+              <a:t>−$363K</a:t>
+            </a:r>
+          </a:p>
+        </p:txBody>
+      </p:sp>
+      <p:sp>
+        <p:nvSpPr>
+          <p:cNvPr id="62" name="TextBox 61"/>
+          <p:cNvSpPr txBox="1"/>
+          <p:nvPr/>
+        </p:nvSpPr>
+        <p:spPr>
+          <a:xfrm>
+            <a:off x="7315200" y="5422392"/>
+            <a:ext cx="2286000" cy="292608"/>
+          </a:xfrm>
+          <a:prstGeom prst="rect">
+            <a:avLst/>
+          </a:prstGeom>
+          <a:noFill/>
+        </p:spPr>
+        <p:txBody>
+          <a:bodyPr wrap="square">
+            <a:spAutoFit/>
+          </a:bodyPr>
+          <a:lstStyle/>
+          <a:p>
+            <a:pPr algn="l"/>
+            <a:r>
+              <a:rPr sz="1100" b="0">
+                <a:solidFill>
+                  <a:srgbClr val="1A2E4A"/>
+                </a:solidFill>
+              </a:rPr>
+              <a:t>Reduce 30%</a:t>
+            </a:r>
+          </a:p>
+        </p:txBody>
+      </p:sp>
+      <p:sp>
+        <p:nvSpPr>
+          <p:cNvPr id="63" name="Rectangle 62"/>
+          <p:cNvSpPr/>
+          <p:nvPr/>
+        </p:nvSpPr>
+        <p:spPr>
+          <a:xfrm>
+            <a:off x="365760" y="5751576"/>
+            <a:ext cx="11430000" cy="347472"/>
+          </a:xfrm>
+          <a:prstGeom prst="rect">
+            <a:avLst/>
+          </a:prstGeom>
+          <a:solidFill>
+            <a:srgbClr val="F4F7FB"/>
+          </a:solidFill>
+          <a:ln>
+            <a:noFill/>
+          </a:ln>
+        </p:spPr>
+        <p:style>
+          <a:lnRef idx="1">
+            <a:schemeClr val="accent1"/>
+          </a:lnRef>
+          <a:fillRef idx="3">
+            <a:schemeClr val="accent1"/>
+          </a:fillRef>
+          <a:effectRef idx="2">
+            <a:schemeClr val="accent1"/>
+          </a:effectRef>
+          <a:fontRef idx="minor">
+            <a:schemeClr val="lt1"/>
+          </a:fontRef>
+        </p:style>
+        <p:txBody>
+          <a:bodyPr rtlCol="0" anchor="ctr"/>
+          <a:lstStyle/>
+          <a:p>
+            <a:pPr algn="ctr"/>
+          </a:p>
+        </p:txBody>
+      </p:sp>
+      <p:sp>
+        <p:nvSpPr>
+          <p:cNvPr id="64" name="TextBox 63"/>
+          <p:cNvSpPr txBox="1"/>
+          <p:nvPr/>
+        </p:nvSpPr>
+        <p:spPr>
+          <a:xfrm>
+            <a:off x="457200" y="5788152"/>
+            <a:ext cx="1554480" cy="292608"/>
+          </a:xfrm>
+          <a:prstGeom prst="rect">
+            <a:avLst/>
+          </a:prstGeom>
+          <a:noFill/>
+        </p:spPr>
+        <p:txBody>
+          <a:bodyPr wrap="square">
+            <a:spAutoFit/>
+          </a:bodyPr>
+          <a:lstStyle/>
+          <a:p>
+            <a:pPr algn="l"/>
+            <a:r>
+              <a:rPr sz="1100" b="0">
+                <a:solidFill>
+                  <a:srgbClr val="1A2E4A"/>
+                </a:solidFill>
+              </a:rPr>
+              <a:t>Display</a:t>
+            </a:r>
+          </a:p>
+        </p:txBody>
+      </p:sp>
+      <p:sp>
+        <p:nvSpPr>
+          <p:cNvPr id="65" name="TextBox 64"/>
+          <p:cNvSpPr txBox="1"/>
+          <p:nvPr/>
+        </p:nvSpPr>
+        <p:spPr>
+          <a:xfrm>
+            <a:off x="2194560" y="5788152"/>
+            <a:ext cx="1097280" cy="292608"/>
+          </a:xfrm>
+          <a:prstGeom prst="rect">
+            <a:avLst/>
+          </a:prstGeom>
+          <a:noFill/>
+        </p:spPr>
+        <p:txBody>
+          <a:bodyPr wrap="square">
+            <a:spAutoFit/>
+          </a:bodyPr>
+          <a:lstStyle/>
+          <a:p>
+            <a:pPr algn="l"/>
+            <a:r>
+              <a:rPr sz="1100" b="0">
+                <a:solidFill>
+                  <a:srgbClr val="C0392B"/>
+                </a:solidFill>
+              </a:rPr>
+              <a:t>1.81×</a:t>
+            </a:r>
+          </a:p>
+        </p:txBody>
+      </p:sp>
+      <p:sp>
+        <p:nvSpPr>
+          <p:cNvPr id="66" name="TextBox 65"/>
+          <p:cNvSpPr txBox="1"/>
+          <p:nvPr/>
+        </p:nvSpPr>
+        <p:spPr>
+          <a:xfrm>
+            <a:off x="3474720" y="5788152"/>
+            <a:ext cx="1097280" cy="292608"/>
+          </a:xfrm>
+          <a:prstGeom prst="rect">
+            <a:avLst/>
+          </a:prstGeom>
+          <a:noFill/>
+        </p:spPr>
+        <p:txBody>
+          <a:bodyPr wrap="square">
+            <a:spAutoFit/>
+          </a:bodyPr>
+          <a:lstStyle/>
+          <a:p>
+            <a:pPr algn="l"/>
+            <a:r>
+              <a:rPr sz="1100" b="0">
+                <a:solidFill>
+                  <a:srgbClr val="1A2E4A"/>
+                </a:solidFill>
+              </a:rPr>
+              <a:t>$1,437K</a:t>
+            </a:r>
+          </a:p>
+        </p:txBody>
+      </p:sp>
+      <p:sp>
+        <p:nvSpPr>
+          <p:cNvPr id="67" name="TextBox 66"/>
+          <p:cNvSpPr txBox="1"/>
+          <p:nvPr/>
+        </p:nvSpPr>
+        <p:spPr>
+          <a:xfrm>
+            <a:off x="4754880" y="5788152"/>
+            <a:ext cx="1097280" cy="292608"/>
+          </a:xfrm>
+          <a:prstGeom prst="rect">
+            <a:avLst/>
+          </a:prstGeom>
+          <a:noFill/>
+        </p:spPr>
+        <p:txBody>
+          <a:bodyPr wrap="square">
+            <a:spAutoFit/>
+          </a:bodyPr>
+          <a:lstStyle/>
+          <a:p>
+            <a:pPr algn="l"/>
+            <a:r>
+              <a:rPr sz="1100" b="0">
+                <a:solidFill>
+                  <a:srgbClr val="1A2E4A"/>
+                </a:solidFill>
+              </a:rPr>
+              <a:t>$1,006K</a:t>
+            </a:r>
+          </a:p>
+        </p:txBody>
+      </p:sp>
+      <p:sp>
+        <p:nvSpPr>
+          <p:cNvPr id="68" name="TextBox 67"/>
+          <p:cNvSpPr txBox="1"/>
+          <p:nvPr/>
+        </p:nvSpPr>
+        <p:spPr>
+          <a:xfrm>
+            <a:off x="6035040" y="5788152"/>
+            <a:ext cx="1097280" cy="292608"/>
+          </a:xfrm>
+          <a:prstGeom prst="rect">
+            <a:avLst/>
+          </a:prstGeom>
+          <a:noFill/>
+        </p:spPr>
+        <p:txBody>
+          <a:bodyPr wrap="square">
+            <a:spAutoFit/>
+          </a:bodyPr>
+          <a:lstStyle/>
+          <a:p>
+            <a:pPr algn="l"/>
+            <a:r>
+              <a:rPr sz="1100" b="1">
+                <a:solidFill>
+                  <a:srgbClr val="C0392B"/>
+                </a:solidFill>
+              </a:rPr>
+              <a:t>−$431K</a:t>
+            </a:r>
+          </a:p>
+        </p:txBody>
+      </p:sp>
+      <p:sp>
+        <p:nvSpPr>
+          <p:cNvPr id="69" name="TextBox 68"/>
+          <p:cNvSpPr txBox="1"/>
+          <p:nvPr/>
+        </p:nvSpPr>
+        <p:spPr>
+          <a:xfrm>
+            <a:off x="7315200" y="5788152"/>
+            <a:ext cx="2286000" cy="292608"/>
+          </a:xfrm>
+          <a:prstGeom prst="rect">
+            <a:avLst/>
+          </a:prstGeom>
+          <a:noFill/>
+        </p:spPr>
+        <p:txBody>
+          <a:bodyPr wrap="square">
+            <a:spAutoFit/>
+          </a:bodyPr>
+          <a:lstStyle/>
+          <a:p>
+            <a:pPr algn="l"/>
+            <a:r>
+              <a:rPr sz="1100" b="0">
+                <a:solidFill>
+                  <a:srgbClr val="1A2E4A"/>
+                </a:solidFill>
+              </a:rPr>
+              <a:t>Reduce 30%</a:t>
+            </a:r>
+          </a:p>
+        </p:txBody>
+      </p:sp>
+      <p:sp>
+        <p:nvSpPr>
+          <p:cNvPr id="70" name="Rectangle 69"/>
+          <p:cNvSpPr/>
+          <p:nvPr/>
+        </p:nvSpPr>
+        <p:spPr>
+          <a:xfrm>
+            <a:off x="365760" y="6117336"/>
+            <a:ext cx="11430000" cy="347472"/>
+          </a:xfrm>
+          <a:prstGeom prst="rect">
+            <a:avLst/>
+          </a:prstGeom>
+          <a:solidFill>
+            <a:srgbClr val="FFFFFF"/>
+          </a:solidFill>
+          <a:ln>
+            <a:noFill/>
+          </a:ln>
+        </p:spPr>
+        <p:style>
+          <a:lnRef idx="1">
+            <a:schemeClr val="accent1"/>
+          </a:lnRef>
+          <a:fillRef idx="3">
+            <a:schemeClr val="accent1"/>
+          </a:fillRef>
+          <a:effectRef idx="2">
+            <a:schemeClr val="accent1"/>
+          </a:effectRef>
+          <a:fontRef idx="minor">
+            <a:schemeClr val="lt1"/>
+          </a:fontRef>
+        </p:style>
+        <p:txBody>
+          <a:bodyPr rtlCol="0" anchor="ctr"/>
+          <a:lstStyle/>
+          <a:p>
+            <a:pPr algn="ctr"/>
+          </a:p>
+        </p:txBody>
+      </p:sp>
+      <p:sp>
+        <p:nvSpPr>
+          <p:cNvPr id="71" name="TextBox 70"/>
+          <p:cNvSpPr txBox="1"/>
+          <p:nvPr/>
+        </p:nvSpPr>
+        <p:spPr>
+          <a:xfrm>
+            <a:off x="457200" y="6153912"/>
+            <a:ext cx="1554480" cy="292608"/>
+          </a:xfrm>
+          <a:prstGeom prst="rect">
+            <a:avLst/>
+          </a:prstGeom>
+          <a:noFill/>
+        </p:spPr>
+        <p:txBody>
+          <a:bodyPr wrap="square">
+            <a:spAutoFit/>
+          </a:bodyPr>
+          <a:lstStyle/>
+          <a:p>
+            <a:pPr algn="l"/>
+            <a:r>
+              <a:rPr sz="1100" b="0">
+                <a:solidFill>
+                  <a:srgbClr val="1A2E4A"/>
+                </a:solidFill>
+              </a:rPr>
+              <a:t>Reddit</a:t>
+            </a:r>
+          </a:p>
+        </p:txBody>
+      </p:sp>
+      <p:sp>
+        <p:nvSpPr>
+          <p:cNvPr id="72" name="TextBox 71"/>
+          <p:cNvSpPr txBox="1"/>
+          <p:nvPr/>
+        </p:nvSpPr>
+        <p:spPr>
+          <a:xfrm>
+            <a:off x="2194560" y="6153912"/>
+            <a:ext cx="1097280" cy="292608"/>
+          </a:xfrm>
+          <a:prstGeom prst="rect">
+            <a:avLst/>
+          </a:prstGeom>
+          <a:noFill/>
+        </p:spPr>
+        <p:txBody>
+          <a:bodyPr wrap="square">
+            <a:spAutoFit/>
+          </a:bodyPr>
+          <a:lstStyle/>
+          <a:p>
+            <a:pPr algn="l"/>
+            <a:r>
+              <a:rPr sz="1100" b="0">
+                <a:solidFill>
+                  <a:srgbClr val="C0392B"/>
+                </a:solidFill>
+              </a:rPr>
+              <a:t>1.61×</a:t>
+            </a:r>
+          </a:p>
+        </p:txBody>
+      </p:sp>
+      <p:sp>
+        <p:nvSpPr>
+          <p:cNvPr id="73" name="TextBox 72"/>
+          <p:cNvSpPr txBox="1"/>
+          <p:nvPr/>
+        </p:nvSpPr>
+        <p:spPr>
+          <a:xfrm>
+            <a:off x="3474720" y="6153912"/>
+            <a:ext cx="1097280" cy="292608"/>
+          </a:xfrm>
+          <a:prstGeom prst="rect">
+            <a:avLst/>
+          </a:prstGeom>
+          <a:noFill/>
+        </p:spPr>
+        <p:txBody>
+          <a:bodyPr wrap="square">
+            <a:spAutoFit/>
+          </a:bodyPr>
+          <a:lstStyle/>
+          <a:p>
+            <a:pPr algn="l"/>
+            <a:r>
+              <a:rPr sz="1100" b="0">
+                <a:solidFill>
+                  <a:srgbClr val="1A2E4A"/>
+                </a:solidFill>
+              </a:rPr>
+              <a:t>$588K</a:t>
+            </a:r>
+          </a:p>
+        </p:txBody>
+      </p:sp>
+      <p:sp>
+        <p:nvSpPr>
+          <p:cNvPr id="74" name="TextBox 73"/>
+          <p:cNvSpPr txBox="1"/>
+          <p:nvPr/>
+        </p:nvSpPr>
+        <p:spPr>
+          <a:xfrm>
+            <a:off x="4754880" y="6153912"/>
+            <a:ext cx="1097280" cy="292608"/>
+          </a:xfrm>
+          <a:prstGeom prst="rect">
+            <a:avLst/>
+          </a:prstGeom>
+          <a:noFill/>
+        </p:spPr>
+        <p:txBody>
+          <a:bodyPr wrap="square">
+            <a:spAutoFit/>
+          </a:bodyPr>
+          <a:lstStyle/>
+          <a:p>
+            <a:pPr algn="l"/>
+            <a:r>
+              <a:rPr sz="1100" b="0">
+                <a:solidFill>
+                  <a:srgbClr val="1A2E4A"/>
+                </a:solidFill>
+              </a:rPr>
+              <a:t>$411K</a:t>
+            </a:r>
+          </a:p>
+        </p:txBody>
+      </p:sp>
+      <p:sp>
+        <p:nvSpPr>
+          <p:cNvPr id="75" name="TextBox 74"/>
+          <p:cNvSpPr txBox="1"/>
+          <p:nvPr/>
+        </p:nvSpPr>
+        <p:spPr>
+          <a:xfrm>
+            <a:off x="6035040" y="6153912"/>
+            <a:ext cx="1097280" cy="292608"/>
+          </a:xfrm>
+          <a:prstGeom prst="rect">
+            <a:avLst/>
+          </a:prstGeom>
+          <a:noFill/>
+        </p:spPr>
+        <p:txBody>
+          <a:bodyPr wrap="square">
+            <a:spAutoFit/>
+          </a:bodyPr>
+          <a:lstStyle/>
+          <a:p>
+            <a:pPr algn="l"/>
+            <a:r>
+              <a:rPr sz="1100" b="1">
+                <a:solidFill>
+                  <a:srgbClr val="C0392B"/>
+                </a:solidFill>
+              </a:rPr>
+              <a:t>−$176K</a:t>
+            </a:r>
+          </a:p>
+        </p:txBody>
+      </p:sp>
+      <p:sp>
+        <p:nvSpPr>
+          <p:cNvPr id="76" name="TextBox 75"/>
+          <p:cNvSpPr txBox="1"/>
+          <p:nvPr/>
+        </p:nvSpPr>
+        <p:spPr>
+          <a:xfrm>
+            <a:off x="7315200" y="6153912"/>
+            <a:ext cx="2286000" cy="292608"/>
+          </a:xfrm>
+          <a:prstGeom prst="rect">
+            <a:avLst/>
+          </a:prstGeom>
+          <a:noFill/>
+        </p:spPr>
+        <p:txBody>
+          <a:bodyPr wrap="square">
+            <a:spAutoFit/>
+          </a:bodyPr>
+          <a:lstStyle/>
+          <a:p>
+            <a:pPr algn="l"/>
+            <a:r>
+              <a:rPr sz="1100" b="0">
+                <a:solidFill>
+                  <a:srgbClr val="1A2E4A"/>
+                </a:solidFill>
+              </a:rPr>
+              <a:t>Reduce 30%</a:t>
+            </a:r>
+          </a:p>
+        </p:txBody>
+      </p:sp>
+      <p:sp>
+        <p:nvSpPr>
+          <p:cNvPr id="77" name="TextBox 76"/>
+          <p:cNvSpPr txBox="1"/>
+          <p:nvPr/>
+        </p:nvSpPr>
+        <p:spPr>
+          <a:xfrm>
+            <a:off x="457200" y="6537960"/>
+            <a:ext cx="10972800" cy="256032"/>
+          </a:xfrm>
+          <a:prstGeom prst="rect">
+            <a:avLst/>
+          </a:prstGeom>
+          <a:noFill/>
+        </p:spPr>
+        <p:txBody>
+          <a:bodyPr wrap="square">
+            <a:spAutoFit/>
+          </a:bodyPr>
+          <a:lstStyle/>
+          <a:p>
+            <a:pPr algn="l"/>
+            <a:r>
+              <a:rPr sz="900" b="0">
                 <a:solidFill>
                   <a:srgbClr val="6B7A90"/>
                 </a:solidFill>
               </a:rPr>
-              <a:t>Facebook/Instagram is the top lead source, which aligns with its strong ROAS — but the low overall win rate suggests that even top-source leads are not converting. Referral is the weakest lead source by volume, which is concerning because referral leads typically convert at 3-5x the rate of paid leads. The lack of referral volume points to a missing advocacy or loyalty program.</a:t>
-            </a:r>
-          </a:p>
-        </p:txBody>
-      </p:sp>
-      <p:sp>
-        <p:nvSpPr>
-          <p:cNvPr id="7" name="TextBox 6"/>
-          <p:cNvSpPr txBox="1"/>
-          <p:nvPr/>
-        </p:nvSpPr>
-        <p:spPr>
-          <a:xfrm>
-            <a:off x="5943600" y="2286000"/>
-            <a:ext cx="5029200" cy="365760"/>
-          </a:xfrm>
-          <a:prstGeom prst="rect">
-            <a:avLst/>
-          </a:prstGeom>
-          <a:noFill/>
-        </p:spPr>
-        <p:txBody>
-          <a:bodyPr wrap="square">
-            <a:spAutoFit/>
-          </a:bodyPr>
-          <a:lstStyle/>
-          <a:p>
-            <a:pPr algn="l"/>
-            <a:r>
-              <a:rPr sz="1500" b="1">
-                <a:solidFill>
-                  <a:srgbClr val="1A2E4A"/>
-                </a:solidFill>
-              </a:rPr>
-              <a:t>Sales Recommendations</a:t>
-            </a:r>
-          </a:p>
-        </p:txBody>
-      </p:sp>
-      <p:sp>
-        <p:nvSpPr>
-          <p:cNvPr id="8" name="TextBox 7"/>
-          <p:cNvSpPr txBox="1"/>
-          <p:nvPr/>
-        </p:nvSpPr>
-        <p:spPr>
-          <a:xfrm>
-            <a:off x="5943600" y="2743200"/>
-            <a:ext cx="5486400" cy="2743200"/>
-          </a:xfrm>
-          <a:prstGeom prst="rect">
-            <a:avLst/>
-          </a:prstGeom>
-          <a:noFill/>
-        </p:spPr>
-        <p:txBody>
-          <a:bodyPr wrap="square">
-            <a:spAutoFit/>
-          </a:bodyPr>
-          <a:lstStyle/>
-          <a:p>
-            <a:pPr>
-              <a:spcAft>
-                <a:spcPts val="600"/>
-              </a:spcAft>
-              <a:defRPr sz="1600">
-                <a:solidFill>
-                  <a:srgbClr val="1A2E4A"/>
-                </a:solidFill>
-              </a:defRPr>
-            </a:pPr>
-            <a:r>
-              <a:t>• Implement lead scoring immediately: Segment the 25K leads by source, engagement level, and deal size to identify which leads are actually converting at scale. Stop routing low-score leads to sales reps — move them to automated nurture sequences.</a:t>
-            </a:r>
-          </a:p>
-          <a:p>
-            <a:pPr>
-              <a:spcAft>
-                <a:spcPts val="600"/>
-              </a:spcAft>
-              <a:defRPr sz="1600">
-                <a:solidFill>
-                  <a:srgbClr val="1A2E4A"/>
-                </a:solidFill>
-              </a:defRPr>
-            </a:pPr>
-            <a:r>
-              <a:t>• Audit the mid-funnel: Map the drop-off points between lead capture and closed-won. A 2.62% rate means 97.4% of leads are dying somewhere — find the specific stage.</a:t>
-            </a:r>
-          </a:p>
-          <a:p>
-            <a:pPr>
-              <a:spcAft>
-                <a:spcPts val="600"/>
-              </a:spcAft>
-              <a:defRPr sz="1600">
-                <a:solidFill>
-                  <a:srgbClr val="1A2E4A"/>
-                </a:solidFill>
-              </a:defRPr>
-            </a:pPr>
-            <a:r>
-              <a:t>• Launch a formal referral program: Referral is the bottom lead source but historically the highest-converting. Offer existing customers a meaningful incentive (discount, exclusive access) to drive referral volume up by 3-5x within 90 days.</a:t>
-            </a:r>
-          </a:p>
-          <a:p>
-            <a:pPr>
-              <a:spcAft>
-                <a:spcPts val="600"/>
-              </a:spcAft>
-              <a:defRPr sz="1600">
-                <a:solidFill>
-                  <a:srgbClr val="1A2E4A"/>
-                </a:solidFill>
-              </a:defRPr>
-            </a:pPr>
-            <a:r>
-              <a:t>• Tighten the Facebook/Instagram-to-sales handoff: As the #1 lead source feeding a low-conversion funnel, even a 1-point improvement in conversion rate on FB/IG leads alone could add $3-5M in pipeline value.</a:t>
+              <a:t>* Incremental revenue assumes 55% of gross ROAS delta applies at margin (accounts for diminishing returns as Email scales).</a:t>
             </a:r>
           </a:p>
         </p:txBody>
@@ -4705,7 +7111,7 @@
                   <a:srgbClr val="FFFFFF"/>
                 </a:solidFill>
               </a:rPr>
-              <a:t>Risks &amp; Opportunities</a:t>
+              <a:t>Sales &amp; Funnel Highlights</a:t>
             </a:r>
           </a:p>
         </p:txBody>
@@ -4718,7 +7124,109 @@
         </p:nvSpPr>
         <p:spPr>
           <a:xfrm>
-            <a:off x="457200" y="1188720"/>
+            <a:off x="731520" y="1280160"/>
+            <a:ext cx="10515600" cy="822960"/>
+          </a:xfrm>
+          <a:prstGeom prst="rect">
+            <a:avLst/>
+          </a:prstGeom>
+          <a:noFill/>
+        </p:spPr>
+        <p:txBody>
+          <a:bodyPr wrap="square">
+            <a:spAutoFit/>
+          </a:bodyPr>
+          <a:lstStyle/>
+          <a:p>
+            <a:pPr algn="l"/>
+            <a:r>
+              <a:rPr sz="1600" b="0">
+                <a:solidFill>
+                  <a:srgbClr val="1A2E4A"/>
+                </a:solidFill>
+              </a:rPr>
+              <a:t>A 2.62% win rate is critically low. Of 25,019 leads, only ~655 converted, generating $31.4M in closed-won pipeline at a $48K average deal value. While the deal size is healthy, the volume of wasted leads suggests the funnel is either attracting unqualified prospects or failing to nurture mid-funnel leads effectively. For context, B2C-adjacent CPG pipelines should target 5-8% conversion rates.</a:t>
+            </a:r>
+          </a:p>
+        </p:txBody>
+      </p:sp>
+      <p:sp>
+        <p:nvSpPr>
+          <p:cNvPr id="5" name="TextBox 4"/>
+          <p:cNvSpPr txBox="1"/>
+          <p:nvPr/>
+        </p:nvSpPr>
+        <p:spPr>
+          <a:xfrm>
+            <a:off x="731520" y="2286000"/>
+            <a:ext cx="3657600" cy="365760"/>
+          </a:xfrm>
+          <a:prstGeom prst="rect">
+            <a:avLst/>
+          </a:prstGeom>
+          <a:noFill/>
+        </p:spPr>
+        <p:txBody>
+          <a:bodyPr wrap="square">
+            <a:spAutoFit/>
+          </a:bodyPr>
+          <a:lstStyle/>
+          <a:p>
+            <a:pPr algn="l"/>
+            <a:r>
+              <a:rPr sz="1500" b="1">
+                <a:solidFill>
+                  <a:srgbClr val="1A2E4A"/>
+                </a:solidFill>
+              </a:rPr>
+              <a:t>Lead Quality Notes</a:t>
+            </a:r>
+          </a:p>
+        </p:txBody>
+      </p:sp>
+      <p:sp>
+        <p:nvSpPr>
+          <p:cNvPr id="6" name="TextBox 5"/>
+          <p:cNvSpPr txBox="1"/>
+          <p:nvPr/>
+        </p:nvSpPr>
+        <p:spPr>
+          <a:xfrm>
+            <a:off x="731520" y="2743200"/>
+            <a:ext cx="4572000" cy="1371600"/>
+          </a:xfrm>
+          <a:prstGeom prst="rect">
+            <a:avLst/>
+          </a:prstGeom>
+          <a:noFill/>
+        </p:spPr>
+        <p:txBody>
+          <a:bodyPr wrap="square">
+            <a:spAutoFit/>
+          </a:bodyPr>
+          <a:lstStyle/>
+          <a:p>
+            <a:pPr algn="l"/>
+            <a:r>
+              <a:rPr sz="1400" b="0">
+                <a:solidFill>
+                  <a:srgbClr val="6B7A90"/>
+                </a:solidFill>
+              </a:rPr>
+              <a:t>Facebook/Instagram is the top lead source, which aligns with its strong ROAS — but the low overall win rate suggests that even top-source leads are not converting. Referral is the weakest lead source by volume, which is concerning because referral leads typically convert at 3-5x the rate of paid leads. The lack of referral volume points to a missing advocacy or loyalty program.</a:t>
+            </a:r>
+          </a:p>
+        </p:txBody>
+      </p:sp>
+      <p:sp>
+        <p:nvSpPr>
+          <p:cNvPr id="7" name="TextBox 6"/>
+          <p:cNvSpPr txBox="1"/>
+          <p:nvPr/>
+        </p:nvSpPr>
+        <p:spPr>
+          <a:xfrm>
+            <a:off x="5943600" y="2286000"/>
             <a:ext cx="5029200" cy="365760"/>
           </a:xfrm>
           <a:prstGeom prst="rect">
@@ -4734,712 +7242,95 @@
           <a:p>
             <a:pPr algn="l"/>
             <a:r>
-              <a:rPr sz="1600" b="1">
-                <a:solidFill>
-                  <a:srgbClr val="C0392B"/>
-                </a:solidFill>
-              </a:rPr>
-              <a:t>Risks</a:t>
-            </a:r>
-          </a:p>
-        </p:txBody>
-      </p:sp>
-      <p:sp>
-        <p:nvSpPr>
-          <p:cNvPr id="5" name="Rectangle 4"/>
-          <p:cNvSpPr/>
-          <p:nvPr/>
-        </p:nvSpPr>
-        <p:spPr>
-          <a:xfrm>
-            <a:off x="457200" y="1645920"/>
-            <a:ext cx="228600" cy="228600"/>
-          </a:xfrm>
-          <a:prstGeom prst="rect">
-            <a:avLst/>
-          </a:prstGeom>
-          <a:solidFill>
-            <a:srgbClr val="C0392B"/>
-          </a:solidFill>
-          <a:ln>
-            <a:noFill/>
-          </a:ln>
-        </p:spPr>
-        <p:style>
-          <a:lnRef idx="1">
-            <a:schemeClr val="accent1"/>
-          </a:lnRef>
-          <a:fillRef idx="3">
-            <a:schemeClr val="accent1"/>
-          </a:fillRef>
-          <a:effectRef idx="2">
-            <a:schemeClr val="accent1"/>
-          </a:effectRef>
-          <a:fontRef idx="minor">
-            <a:schemeClr val="lt1"/>
-          </a:fontRef>
-        </p:style>
-        <p:txBody>
-          <a:bodyPr rtlCol="0" anchor="ctr"/>
-          <a:lstStyle/>
-          <a:p>
-            <a:pPr algn="ctr"/>
-          </a:p>
-        </p:txBody>
-      </p:sp>
-      <p:sp>
-        <p:nvSpPr>
-          <p:cNvPr id="6" name="TextBox 5"/>
-          <p:cNvSpPr txBox="1"/>
-          <p:nvPr/>
-        </p:nvSpPr>
-        <p:spPr>
-          <a:xfrm>
-            <a:off x="777240" y="1600200"/>
-            <a:ext cx="4572000" cy="320040"/>
-          </a:xfrm>
-          <a:prstGeom prst="rect">
-            <a:avLst/>
-          </a:prstGeom>
-          <a:noFill/>
-        </p:spPr>
-        <p:txBody>
-          <a:bodyPr wrap="square">
-            <a:spAutoFit/>
-          </a:bodyPr>
-          <a:lstStyle/>
-          <a:p>
-            <a:pPr algn="l"/>
-            <a:r>
-              <a:rPr sz="1400" b="0">
+              <a:rPr sz="1500" b="1">
                 <a:solidFill>
                   <a:srgbClr val="1A2E4A"/>
                 </a:solidFill>
               </a:rPr>
-              <a:t>2.62% funnel win rate is burning acquisition investment — at current CPLs, the business is spending heavily to generate leads that never convert, dragging down effective ROAS across all channels.</a:t>
-            </a:r>
-          </a:p>
-        </p:txBody>
-      </p:sp>
-      <p:sp>
-        <p:nvSpPr>
-          <p:cNvPr id="7" name="TextBox 6"/>
-          <p:cNvSpPr txBox="1"/>
-          <p:nvPr/>
-        </p:nvSpPr>
-        <p:spPr>
-          <a:xfrm>
-            <a:off x="777240" y="1920240"/>
-            <a:ext cx="4572000" cy="320040"/>
-          </a:xfrm>
-          <a:prstGeom prst="rect">
-            <a:avLst/>
-          </a:prstGeom>
-          <a:noFill/>
-        </p:spPr>
-        <p:txBody>
-          <a:bodyPr wrap="square">
-            <a:spAutoFit/>
-          </a:bodyPr>
-          <a:lstStyle/>
-          <a:p>
-            <a:pPr algn="l"/>
-            <a:r>
-              <a:rPr sz="1200" b="0">
-                <a:solidFill>
-                  <a:srgbClr val="6B7A90"/>
-                </a:solidFill>
-              </a:rPr>
-              <a:t>Action: Launch a lead quality audit and scoring system within 30 days. Pause or redirect spend on lead sources with below-1% conversion rates.</a:t>
-            </a:r>
-          </a:p>
-        </p:txBody>
-      </p:sp>
-      <p:sp>
-        <p:nvSpPr>
-          <p:cNvPr id="8" name="Rectangle 7"/>
-          <p:cNvSpPr/>
-          <p:nvPr/>
-        </p:nvSpPr>
-        <p:spPr>
-          <a:xfrm>
-            <a:off x="457200" y="2423160"/>
-            <a:ext cx="228600" cy="228600"/>
-          </a:xfrm>
-          <a:prstGeom prst="rect">
-            <a:avLst/>
-          </a:prstGeom>
-          <a:solidFill>
-            <a:srgbClr val="C0392B"/>
-          </a:solidFill>
-          <a:ln>
-            <a:noFill/>
-          </a:ln>
-        </p:spPr>
-        <p:style>
-          <a:lnRef idx="1">
-            <a:schemeClr val="accent1"/>
-          </a:lnRef>
-          <a:fillRef idx="3">
-            <a:schemeClr val="accent1"/>
-          </a:fillRef>
-          <a:effectRef idx="2">
-            <a:schemeClr val="accent1"/>
-          </a:effectRef>
-          <a:fontRef idx="minor">
-            <a:schemeClr val="lt1"/>
-          </a:fontRef>
-        </p:style>
-        <p:txBody>
-          <a:bodyPr rtlCol="0" anchor="ctr"/>
-          <a:lstStyle/>
-          <a:p>
-            <a:pPr algn="ctr"/>
-          </a:p>
-        </p:txBody>
-      </p:sp>
-      <p:sp>
-        <p:nvSpPr>
-          <p:cNvPr id="9" name="TextBox 8"/>
-          <p:cNvSpPr txBox="1"/>
-          <p:nvPr/>
-        </p:nvSpPr>
-        <p:spPr>
-          <a:xfrm>
-            <a:off x="777240" y="2377440"/>
-            <a:ext cx="4572000" cy="320040"/>
-          </a:xfrm>
-          <a:prstGeom prst="rect">
-            <a:avLst/>
-          </a:prstGeom>
-          <a:noFill/>
-        </p:spPr>
-        <p:txBody>
-          <a:bodyPr wrap="square">
-            <a:spAutoFit/>
-          </a:bodyPr>
-          <a:lstStyle/>
-          <a:p>
-            <a:pPr algn="l"/>
-            <a:r>
-              <a:rPr sz="1400" b="0">
+              <a:t>Sales Recommendations</a:t>
+            </a:r>
+          </a:p>
+        </p:txBody>
+      </p:sp>
+      <p:sp>
+        <p:nvSpPr>
+          <p:cNvPr id="8" name="TextBox 7"/>
+          <p:cNvSpPr txBox="1"/>
+          <p:nvPr/>
+        </p:nvSpPr>
+        <p:spPr>
+          <a:xfrm>
+            <a:off x="5943600" y="2743200"/>
+            <a:ext cx="5486400" cy="2743200"/>
+          </a:xfrm>
+          <a:prstGeom prst="rect">
+            <a:avLst/>
+          </a:prstGeom>
+          <a:noFill/>
+        </p:spPr>
+        <p:txBody>
+          <a:bodyPr wrap="square">
+            <a:spAutoFit/>
+          </a:bodyPr>
+          <a:lstStyle/>
+          <a:p>
+            <a:pPr>
+              <a:spcAft>
+                <a:spcPts val="600"/>
+              </a:spcAft>
+              <a:defRPr sz="1600">
                 <a:solidFill>
                   <a:srgbClr val="1A2E4A"/>
                 </a:solidFill>
-              </a:rPr>
-              <a:t>TV/CTV commands 37% of media budget ($5.6M) with only 2.34 ROAS and no incrementality validation — there is a material risk that a significant portion of this spend is capturing organic or search-driven demand rather than creating it.</a:t>
-            </a:r>
-          </a:p>
-        </p:txBody>
-      </p:sp>
-      <p:sp>
-        <p:nvSpPr>
-          <p:cNvPr id="10" name="TextBox 9"/>
-          <p:cNvSpPr txBox="1"/>
-          <p:nvPr/>
-        </p:nvSpPr>
-        <p:spPr>
-          <a:xfrm>
-            <a:off x="777240" y="2697480"/>
-            <a:ext cx="4572000" cy="320040"/>
-          </a:xfrm>
-          <a:prstGeom prst="rect">
-            <a:avLst/>
-          </a:prstGeom>
-          <a:noFill/>
-        </p:spPr>
-        <p:txBody>
-          <a:bodyPr wrap="square">
-            <a:spAutoFit/>
-          </a:bodyPr>
-          <a:lstStyle/>
-          <a:p>
-            <a:pPr algn="l"/>
-            <a:r>
-              <a:rPr sz="1200" b="0">
-                <a:solidFill>
-                  <a:srgbClr val="6B7A90"/>
-                </a:solidFill>
-              </a:rPr>
-              <a:t>Action: Commission a geo-holdout or incrementality test on TV/CTV within this quarter. If true incremental ROAS falls below 1.5, reallocate $1-2M to proven digital performers.</a:t>
-            </a:r>
-          </a:p>
-        </p:txBody>
-      </p:sp>
-      <p:sp>
-        <p:nvSpPr>
-          <p:cNvPr id="11" name="Rectangle 10"/>
-          <p:cNvSpPr/>
-          <p:nvPr/>
-        </p:nvSpPr>
-        <p:spPr>
-          <a:xfrm>
-            <a:off x="457200" y="3200400"/>
-            <a:ext cx="228600" cy="228600"/>
-          </a:xfrm>
-          <a:prstGeom prst="rect">
-            <a:avLst/>
-          </a:prstGeom>
-          <a:solidFill>
-            <a:srgbClr val="E67E22"/>
-          </a:solidFill>
-          <a:ln>
-            <a:noFill/>
-          </a:ln>
-        </p:spPr>
-        <p:style>
-          <a:lnRef idx="1">
-            <a:schemeClr val="accent1"/>
-          </a:lnRef>
-          <a:fillRef idx="3">
-            <a:schemeClr val="accent1"/>
-          </a:fillRef>
-          <a:effectRef idx="2">
-            <a:schemeClr val="accent1"/>
-          </a:effectRef>
-          <a:fontRef idx="minor">
-            <a:schemeClr val="lt1"/>
-          </a:fontRef>
-        </p:style>
-        <p:txBody>
-          <a:bodyPr rtlCol="0" anchor="ctr"/>
-          <a:lstStyle/>
-          <a:p>
-            <a:pPr algn="ctr"/>
-          </a:p>
-        </p:txBody>
-      </p:sp>
-      <p:sp>
-        <p:nvSpPr>
-          <p:cNvPr id="12" name="TextBox 11"/>
-          <p:cNvSpPr txBox="1"/>
-          <p:nvPr/>
-        </p:nvSpPr>
-        <p:spPr>
-          <a:xfrm>
-            <a:off x="777240" y="3154680"/>
-            <a:ext cx="4572000" cy="320040"/>
-          </a:xfrm>
-          <a:prstGeom prst="rect">
-            <a:avLst/>
-          </a:prstGeom>
-          <a:noFill/>
-        </p:spPr>
-        <p:txBody>
-          <a:bodyPr wrap="square">
-            <a:spAutoFit/>
-          </a:bodyPr>
-          <a:lstStyle/>
-          <a:p>
-            <a:pPr algn="l"/>
-            <a:r>
-              <a:rPr sz="1400" b="0">
+              </a:defRPr>
+            </a:pPr>
+            <a:r>
+              <a:t>• Implement lead scoring immediately: Segment the 25K leads by source, engagement level, and deal size to identify which leads are actually converting at scale. Stop routing low-score leads to sales reps — move them to automated nurture sequences.</a:t>
+            </a:r>
+          </a:p>
+          <a:p>
+            <a:pPr>
+              <a:spcAft>
+                <a:spcPts val="600"/>
+              </a:spcAft>
+              <a:defRPr sz="1600">
                 <a:solidFill>
                   <a:srgbClr val="1A2E4A"/>
                 </a:solidFill>
-              </a:rPr>
-              <a:t>Over-reliance on Northeast region (27.4% of offline revenue). Any regional disruption — retailer delistings, competitive entry, weather events — disproportionately impacts total offline performance.</a:t>
-            </a:r>
-          </a:p>
-        </p:txBody>
-      </p:sp>
-      <p:sp>
-        <p:nvSpPr>
-          <p:cNvPr id="13" name="TextBox 12"/>
-          <p:cNvSpPr txBox="1"/>
-          <p:nvPr/>
-        </p:nvSpPr>
-        <p:spPr>
-          <a:xfrm>
-            <a:off x="777240" y="3474720"/>
-            <a:ext cx="4572000" cy="320040"/>
-          </a:xfrm>
-          <a:prstGeom prst="rect">
-            <a:avLst/>
-          </a:prstGeom>
-          <a:noFill/>
-        </p:spPr>
-        <p:txBody>
-          <a:bodyPr wrap="square">
-            <a:spAutoFit/>
-          </a:bodyPr>
-          <a:lstStyle/>
-          <a:p>
-            <a:pPr algn="l"/>
-            <a:r>
-              <a:rPr sz="1200" b="0">
-                <a:solidFill>
-                  <a:srgbClr val="6B7A90"/>
-                </a:solidFill>
-              </a:rPr>
-              <a:t>Action: Develop a Southwest and West growth plan targeting the $5-6M gap to Northeast, with regional trade promotions and expanded distribution within 90 days.</a:t>
-            </a:r>
-          </a:p>
-        </p:txBody>
-      </p:sp>
-      <p:sp>
-        <p:nvSpPr>
-          <p:cNvPr id="14" name="TextBox 13"/>
-          <p:cNvSpPr txBox="1"/>
-          <p:nvPr/>
-        </p:nvSpPr>
-        <p:spPr>
-          <a:xfrm>
-            <a:off x="6400800" y="1188720"/>
-            <a:ext cx="5029200" cy="365760"/>
-          </a:xfrm>
-          <a:prstGeom prst="rect">
-            <a:avLst/>
-          </a:prstGeom>
-          <a:noFill/>
-        </p:spPr>
-        <p:txBody>
-          <a:bodyPr wrap="square">
-            <a:spAutoFit/>
-          </a:bodyPr>
-          <a:lstStyle/>
-          <a:p>
-            <a:pPr algn="l"/>
-            <a:r>
-              <a:rPr sz="1600" b="1">
-                <a:solidFill>
-                  <a:srgbClr val="27AE60"/>
-                </a:solidFill>
-              </a:rPr>
-              <a:t>Opportunities</a:t>
-            </a:r>
-          </a:p>
-        </p:txBody>
-      </p:sp>
-      <p:sp>
-        <p:nvSpPr>
-          <p:cNvPr id="15" name="Rectangle 14"/>
-          <p:cNvSpPr/>
-          <p:nvPr/>
-        </p:nvSpPr>
-        <p:spPr>
-          <a:xfrm>
-            <a:off x="6400800" y="1645920"/>
-            <a:ext cx="228600" cy="228600"/>
-          </a:xfrm>
-          <a:prstGeom prst="rect">
-            <a:avLst/>
-          </a:prstGeom>
-          <a:solidFill>
-            <a:srgbClr val="27AE60"/>
-          </a:solidFill>
-          <a:ln>
-            <a:noFill/>
-          </a:ln>
-        </p:spPr>
-        <p:style>
-          <a:lnRef idx="1">
-            <a:schemeClr val="accent1"/>
-          </a:lnRef>
-          <a:fillRef idx="3">
-            <a:schemeClr val="accent1"/>
-          </a:fillRef>
-          <a:effectRef idx="2">
-            <a:schemeClr val="accent1"/>
-          </a:effectRef>
-          <a:fontRef idx="minor">
-            <a:schemeClr val="lt1"/>
-          </a:fontRef>
-        </p:style>
-        <p:txBody>
-          <a:bodyPr rtlCol="0" anchor="ctr"/>
-          <a:lstStyle/>
-          <a:p>
-            <a:pPr algn="ctr"/>
-          </a:p>
-        </p:txBody>
-      </p:sp>
-      <p:sp>
-        <p:nvSpPr>
-          <p:cNvPr id="16" name="TextBox 15"/>
-          <p:cNvSpPr txBox="1"/>
-          <p:nvPr/>
-        </p:nvSpPr>
-        <p:spPr>
-          <a:xfrm>
-            <a:off x="6720840" y="1600200"/>
-            <a:ext cx="5029200" cy="320040"/>
-          </a:xfrm>
-          <a:prstGeom prst="rect">
-            <a:avLst/>
-          </a:prstGeom>
-          <a:noFill/>
-        </p:spPr>
-        <p:txBody>
-          <a:bodyPr wrap="square">
-            <a:spAutoFit/>
-          </a:bodyPr>
-          <a:lstStyle/>
-          <a:p>
-            <a:pPr algn="l"/>
-            <a:r>
-              <a:rPr sz="1400" b="0">
+              </a:defRPr>
+            </a:pPr>
+            <a:r>
+              <a:t>• Audit the mid-funnel: Map the drop-off points between lead capture and closed-won. A 2.62% rate means 97.4% of leads are dying somewhere — find the specific stage.</a:t>
+            </a:r>
+          </a:p>
+          <a:p>
+            <a:pPr>
+              <a:spcAft>
+                <a:spcPts val="600"/>
+              </a:spcAft>
+              <a:defRPr sz="1600">
                 <a:solidFill>
                   <a:srgbClr val="1A2E4A"/>
                 </a:solidFill>
-              </a:rPr>
-              <a:t>Scale Email channel from $527K to $1M+ — it is delivering 6.39 ROAS and is the most underfunded channel by a wide margin. Every additional dollar here works nearly 3x harder than the blended average.</a:t>
-            </a:r>
-          </a:p>
-        </p:txBody>
-      </p:sp>
-      <p:sp>
-        <p:nvSpPr>
-          <p:cNvPr id="17" name="TextBox 16"/>
-          <p:cNvSpPr txBox="1"/>
-          <p:nvPr/>
-        </p:nvSpPr>
-        <p:spPr>
-          <a:xfrm>
-            <a:off x="6720840" y="1920240"/>
-            <a:ext cx="5029200" cy="320040"/>
-          </a:xfrm>
-          <a:prstGeom prst="rect">
-            <a:avLst/>
-          </a:prstGeom>
-          <a:noFill/>
-        </p:spPr>
-        <p:txBody>
-          <a:bodyPr wrap="square">
-            <a:spAutoFit/>
-          </a:bodyPr>
-          <a:lstStyle/>
-          <a:p>
-            <a:pPr algn="l"/>
-            <a:r>
-              <a:rPr sz="1200" b="0">
-                <a:solidFill>
-                  <a:srgbClr val="6B7A90"/>
-                </a:solidFill>
-              </a:rPr>
-              <a:t>Impact: $2.0-3.0M incremental revenue on $500K additional spend  |  30 days</a:t>
-            </a:r>
-          </a:p>
-        </p:txBody>
-      </p:sp>
-      <p:sp>
-        <p:nvSpPr>
-          <p:cNvPr id="18" name="Rectangle 17"/>
-          <p:cNvSpPr/>
-          <p:nvPr/>
-        </p:nvSpPr>
-        <p:spPr>
-          <a:xfrm>
-            <a:off x="6400800" y="2423160"/>
-            <a:ext cx="228600" cy="228600"/>
-          </a:xfrm>
-          <a:prstGeom prst="rect">
-            <a:avLst/>
-          </a:prstGeom>
-          <a:solidFill>
-            <a:srgbClr val="27AE60"/>
-          </a:solidFill>
-          <a:ln>
-            <a:noFill/>
-          </a:ln>
-        </p:spPr>
-        <p:style>
-          <a:lnRef idx="1">
-            <a:schemeClr val="accent1"/>
-          </a:lnRef>
-          <a:fillRef idx="3">
-            <a:schemeClr val="accent1"/>
-          </a:fillRef>
-          <a:effectRef idx="2">
-            <a:schemeClr val="accent1"/>
-          </a:effectRef>
-          <a:fontRef idx="minor">
-            <a:schemeClr val="lt1"/>
-          </a:fontRef>
-        </p:style>
-        <p:txBody>
-          <a:bodyPr rtlCol="0" anchor="ctr"/>
-          <a:lstStyle/>
-          <a:p>
-            <a:pPr algn="ctr"/>
-          </a:p>
-        </p:txBody>
-      </p:sp>
-      <p:sp>
-        <p:nvSpPr>
-          <p:cNvPr id="19" name="TextBox 18"/>
-          <p:cNvSpPr txBox="1"/>
-          <p:nvPr/>
-        </p:nvSpPr>
-        <p:spPr>
-          <a:xfrm>
-            <a:off x="6720840" y="2377440"/>
-            <a:ext cx="5029200" cy="320040"/>
-          </a:xfrm>
-          <a:prstGeom prst="rect">
-            <a:avLst/>
-          </a:prstGeom>
-          <a:noFill/>
-        </p:spPr>
-        <p:txBody>
-          <a:bodyPr wrap="square">
-            <a:spAutoFit/>
-          </a:bodyPr>
-          <a:lstStyle/>
-          <a:p>
-            <a:pPr algn="l"/>
-            <a:r>
-              <a:rPr sz="1400" b="0">
+              </a:defRPr>
+            </a:pPr>
+            <a:r>
+              <a:t>• Launch a formal referral program: Referral is the bottom lead source but historically the highest-converting. Offer existing customers a meaningful incentive (discount, exclusive access) to drive referral volume up by 3-5x within 90 days.</a:t>
+            </a:r>
+          </a:p>
+          <a:p>
+            <a:pPr>
+              <a:spcAft>
+                <a:spcPts val="600"/>
+              </a:spcAft>
+              <a:defRPr sz="1600">
                 <a:solidFill>
                   <a:srgbClr val="1A2E4A"/>
                 </a:solidFill>
-              </a:rPr>
-              <a:t>Fix funnel conversion from 2.62% to 4.0% through lead scoring, mid-funnel nurture automation, and sales process optimization. On the existing 25K lead base, this adds ~345 incremental deals.</a:t>
-            </a:r>
-          </a:p>
-        </p:txBody>
-      </p:sp>
-      <p:sp>
-        <p:nvSpPr>
-          <p:cNvPr id="20" name="TextBox 19"/>
-          <p:cNvSpPr txBox="1"/>
-          <p:nvPr/>
-        </p:nvSpPr>
-        <p:spPr>
-          <a:xfrm>
-            <a:off x="6720840" y="2697480"/>
-            <a:ext cx="5029200" cy="320040"/>
-          </a:xfrm>
-          <a:prstGeom prst="rect">
-            <a:avLst/>
-          </a:prstGeom>
-          <a:noFill/>
-        </p:spPr>
-        <p:txBody>
-          <a:bodyPr wrap="square">
-            <a:spAutoFit/>
-          </a:bodyPr>
-          <a:lstStyle/>
-          <a:p>
-            <a:pPr algn="l"/>
-            <a:r>
-              <a:rPr sz="1200" b="0">
-                <a:solidFill>
-                  <a:srgbClr val="6B7A90"/>
-                </a:solidFill>
-              </a:rPr>
-              <a:t>Impact: $16.6M in additional closed-won pipeline (345 deals × $48K average deal value)  |  60-90 days</a:t>
-            </a:r>
-          </a:p>
-        </p:txBody>
-      </p:sp>
-      <p:sp>
-        <p:nvSpPr>
-          <p:cNvPr id="21" name="Rectangle 20"/>
-          <p:cNvSpPr/>
-          <p:nvPr/>
-        </p:nvSpPr>
-        <p:spPr>
-          <a:xfrm>
-            <a:off x="6400800" y="3200400"/>
-            <a:ext cx="228600" cy="228600"/>
-          </a:xfrm>
-          <a:prstGeom prst="rect">
-            <a:avLst/>
-          </a:prstGeom>
-          <a:solidFill>
-            <a:srgbClr val="27AE60"/>
-          </a:solidFill>
-          <a:ln>
-            <a:noFill/>
-          </a:ln>
-        </p:spPr>
-        <p:style>
-          <a:lnRef idx="1">
-            <a:schemeClr val="accent1"/>
-          </a:lnRef>
-          <a:fillRef idx="3">
-            <a:schemeClr val="accent1"/>
-          </a:fillRef>
-          <a:effectRef idx="2">
-            <a:schemeClr val="accent1"/>
-          </a:effectRef>
-          <a:fontRef idx="minor">
-            <a:schemeClr val="lt1"/>
-          </a:fontRef>
-        </p:style>
-        <p:txBody>
-          <a:bodyPr rtlCol="0" anchor="ctr"/>
-          <a:lstStyle/>
-          <a:p>
-            <a:pPr algn="ctr"/>
-          </a:p>
-        </p:txBody>
-      </p:sp>
-      <p:sp>
-        <p:nvSpPr>
-          <p:cNvPr id="22" name="TextBox 21"/>
-          <p:cNvSpPr txBox="1"/>
-          <p:nvPr/>
-        </p:nvSpPr>
-        <p:spPr>
-          <a:xfrm>
-            <a:off x="6720840" y="3154680"/>
-            <a:ext cx="5029200" cy="320040"/>
-          </a:xfrm>
-          <a:prstGeom prst="rect">
-            <a:avLst/>
-          </a:prstGeom>
-          <a:noFill/>
-        </p:spPr>
-        <p:txBody>
-          <a:bodyPr wrap="square">
-            <a:spAutoFit/>
-          </a:bodyPr>
-          <a:lstStyle/>
-          <a:p>
-            <a:pPr algn="l"/>
-            <a:r>
-              <a:rPr sz="1400" b="0">
-                <a:solidFill>
-                  <a:srgbClr val="1A2E4A"/>
-                </a:solidFill>
-              </a:rPr>
-              <a:t>Launch a structured customer referral program to activate the weakest but highest-potential lead source. Referral leads convert at industry rates of 10-15%, vs. the current blended 2.62%.</a:t>
-            </a:r>
-          </a:p>
-        </p:txBody>
-      </p:sp>
-      <p:sp>
-        <p:nvSpPr>
-          <p:cNvPr id="23" name="TextBox 22"/>
-          <p:cNvSpPr txBox="1"/>
-          <p:nvPr/>
-        </p:nvSpPr>
-        <p:spPr>
-          <a:xfrm>
-            <a:off x="6720840" y="3474720"/>
-            <a:ext cx="5029200" cy="320040"/>
-          </a:xfrm>
-          <a:prstGeom prst="rect">
-            <a:avLst/>
-          </a:prstGeom>
-          <a:noFill/>
-        </p:spPr>
-        <p:txBody>
-          <a:bodyPr wrap="square">
-            <a:spAutoFit/>
-          </a:bodyPr>
-          <a:lstStyle/>
-          <a:p>
-            <a:pPr algn="l"/>
-            <a:r>
-              <a:rPr sz="1200" b="0">
-                <a:solidFill>
-                  <a:srgbClr val="6B7A90"/>
-                </a:solidFill>
-              </a:rPr>
-              <a:t>Impact: $5-8M in high-quality pipeline within 6 months if referral volume reaches 2,000+ leads  |  60 days to launch</a:t>
+              </a:defRPr>
+            </a:pPr>
+            <a:r>
+              <a:t>• Tighten the Facebook/Instagram-to-sales handoff: As the #1 lead source feeding a low-conversion funnel, even a 1-point improvement in conversion rate on FB/IG leads alone could add $3-5M in pipeline value.</a:t>
             </a:r>
           </a:p>
         </p:txBody>
@@ -5453,6 +7344,843 @@
 </file>
 
 <file path=ppt/slides/slide6.xml><?xml version="1.0" encoding="utf-8"?>
+<p:sld xmlns:a="http://schemas.openxmlformats.org/drawingml/2006/main" xmlns:p="http://schemas.openxmlformats.org/presentationml/2006/main" xmlns:r="http://schemas.openxmlformats.org/officeDocument/2006/relationships">
+  <p:cSld>
+    <p:bg>
+      <p:bgPr>
+        <a:solidFill>
+          <a:srgbClr val="F4F7FB"/>
+        </a:solidFill>
+        <a:effectLst/>
+      </p:bgPr>
+    </p:bg>
+    <p:spTree>
+      <p:nvGrpSpPr>
+        <p:cNvPr id="1" name=""/>
+        <p:cNvGrpSpPr/>
+        <p:nvPr/>
+      </p:nvGrpSpPr>
+      <p:grpSpPr/>
+      <p:sp>
+        <p:nvSpPr>
+          <p:cNvPr id="2" name="Rectangle 1"/>
+          <p:cNvSpPr/>
+          <p:nvPr/>
+        </p:nvSpPr>
+        <p:spPr>
+          <a:xfrm>
+            <a:off x="0" y="0"/>
+            <a:ext cx="12188952" cy="1005840"/>
+          </a:xfrm>
+          <a:prstGeom prst="rect">
+            <a:avLst/>
+          </a:prstGeom>
+          <a:solidFill>
+            <a:srgbClr val="1A2E4A"/>
+          </a:solidFill>
+          <a:ln>
+            <a:noFill/>
+          </a:ln>
+        </p:spPr>
+        <p:style>
+          <a:lnRef idx="1">
+            <a:schemeClr val="accent1"/>
+          </a:lnRef>
+          <a:fillRef idx="3">
+            <a:schemeClr val="accent1"/>
+          </a:fillRef>
+          <a:effectRef idx="2">
+            <a:schemeClr val="accent1"/>
+          </a:effectRef>
+          <a:fontRef idx="minor">
+            <a:schemeClr val="lt1"/>
+          </a:fontRef>
+        </p:style>
+        <p:txBody>
+          <a:bodyPr rtlCol="0" anchor="ctr"/>
+          <a:lstStyle/>
+          <a:p>
+            <a:pPr algn="ctr"/>
+          </a:p>
+        </p:txBody>
+      </p:sp>
+      <p:sp>
+        <p:nvSpPr>
+          <p:cNvPr id="3" name="TextBox 2"/>
+          <p:cNvSpPr txBox="1"/>
+          <p:nvPr/>
+        </p:nvSpPr>
+        <p:spPr>
+          <a:xfrm>
+            <a:off x="457200" y="182880"/>
+            <a:ext cx="10972800" cy="640080"/>
+          </a:xfrm>
+          <a:prstGeom prst="rect">
+            <a:avLst/>
+          </a:prstGeom>
+          <a:noFill/>
+        </p:spPr>
+        <p:txBody>
+          <a:bodyPr wrap="square">
+            <a:spAutoFit/>
+          </a:bodyPr>
+          <a:lstStyle/>
+          <a:p>
+            <a:pPr algn="l"/>
+            <a:r>
+              <a:rPr sz="2600" b="1">
+                <a:solidFill>
+                  <a:srgbClr val="FFFFFF"/>
+                </a:solidFill>
+              </a:rPr>
+              <a:t>Risks &amp; Opportunities</a:t>
+            </a:r>
+          </a:p>
+        </p:txBody>
+      </p:sp>
+      <p:sp>
+        <p:nvSpPr>
+          <p:cNvPr id="4" name="TextBox 3"/>
+          <p:cNvSpPr txBox="1"/>
+          <p:nvPr/>
+        </p:nvSpPr>
+        <p:spPr>
+          <a:xfrm>
+            <a:off x="457200" y="1188720"/>
+            <a:ext cx="5029200" cy="365760"/>
+          </a:xfrm>
+          <a:prstGeom prst="rect">
+            <a:avLst/>
+          </a:prstGeom>
+          <a:noFill/>
+        </p:spPr>
+        <p:txBody>
+          <a:bodyPr wrap="square">
+            <a:spAutoFit/>
+          </a:bodyPr>
+          <a:lstStyle/>
+          <a:p>
+            <a:pPr algn="l"/>
+            <a:r>
+              <a:rPr sz="1600" b="1">
+                <a:solidFill>
+                  <a:srgbClr val="C0392B"/>
+                </a:solidFill>
+              </a:rPr>
+              <a:t>Risks</a:t>
+            </a:r>
+          </a:p>
+        </p:txBody>
+      </p:sp>
+      <p:sp>
+        <p:nvSpPr>
+          <p:cNvPr id="5" name="Rectangle 4"/>
+          <p:cNvSpPr/>
+          <p:nvPr/>
+        </p:nvSpPr>
+        <p:spPr>
+          <a:xfrm>
+            <a:off x="457200" y="1645920"/>
+            <a:ext cx="228600" cy="228600"/>
+          </a:xfrm>
+          <a:prstGeom prst="rect">
+            <a:avLst/>
+          </a:prstGeom>
+          <a:solidFill>
+            <a:srgbClr val="C0392B"/>
+          </a:solidFill>
+          <a:ln>
+            <a:noFill/>
+          </a:ln>
+        </p:spPr>
+        <p:style>
+          <a:lnRef idx="1">
+            <a:schemeClr val="accent1"/>
+          </a:lnRef>
+          <a:fillRef idx="3">
+            <a:schemeClr val="accent1"/>
+          </a:fillRef>
+          <a:effectRef idx="2">
+            <a:schemeClr val="accent1"/>
+          </a:effectRef>
+          <a:fontRef idx="minor">
+            <a:schemeClr val="lt1"/>
+          </a:fontRef>
+        </p:style>
+        <p:txBody>
+          <a:bodyPr rtlCol="0" anchor="ctr"/>
+          <a:lstStyle/>
+          <a:p>
+            <a:pPr algn="ctr"/>
+          </a:p>
+        </p:txBody>
+      </p:sp>
+      <p:sp>
+        <p:nvSpPr>
+          <p:cNvPr id="6" name="TextBox 5"/>
+          <p:cNvSpPr txBox="1"/>
+          <p:nvPr/>
+        </p:nvSpPr>
+        <p:spPr>
+          <a:xfrm>
+            <a:off x="777240" y="1600200"/>
+            <a:ext cx="4572000" cy="320040"/>
+          </a:xfrm>
+          <a:prstGeom prst="rect">
+            <a:avLst/>
+          </a:prstGeom>
+          <a:noFill/>
+        </p:spPr>
+        <p:txBody>
+          <a:bodyPr wrap="square">
+            <a:spAutoFit/>
+          </a:bodyPr>
+          <a:lstStyle/>
+          <a:p>
+            <a:pPr algn="l"/>
+            <a:r>
+              <a:rPr sz="1400" b="0">
+                <a:solidFill>
+                  <a:srgbClr val="1A2E4A"/>
+                </a:solidFill>
+              </a:rPr>
+              <a:t>2.62% funnel win rate is burning acquisition investment — at current CPLs, the business is spending heavily to generate leads that never convert, dragging down effective ROAS across all channels.</a:t>
+            </a:r>
+          </a:p>
+        </p:txBody>
+      </p:sp>
+      <p:sp>
+        <p:nvSpPr>
+          <p:cNvPr id="7" name="TextBox 6"/>
+          <p:cNvSpPr txBox="1"/>
+          <p:nvPr/>
+        </p:nvSpPr>
+        <p:spPr>
+          <a:xfrm>
+            <a:off x="777240" y="1920240"/>
+            <a:ext cx="4572000" cy="320040"/>
+          </a:xfrm>
+          <a:prstGeom prst="rect">
+            <a:avLst/>
+          </a:prstGeom>
+          <a:noFill/>
+        </p:spPr>
+        <p:txBody>
+          <a:bodyPr wrap="square">
+            <a:spAutoFit/>
+          </a:bodyPr>
+          <a:lstStyle/>
+          <a:p>
+            <a:pPr algn="l"/>
+            <a:r>
+              <a:rPr sz="1200" b="0">
+                <a:solidFill>
+                  <a:srgbClr val="6B7A90"/>
+                </a:solidFill>
+              </a:rPr>
+              <a:t>Action: Launch a lead quality audit and scoring system within 30 days. Pause or redirect spend on lead sources with below-1% conversion rates.</a:t>
+            </a:r>
+          </a:p>
+        </p:txBody>
+      </p:sp>
+      <p:sp>
+        <p:nvSpPr>
+          <p:cNvPr id="8" name="Rectangle 7"/>
+          <p:cNvSpPr/>
+          <p:nvPr/>
+        </p:nvSpPr>
+        <p:spPr>
+          <a:xfrm>
+            <a:off x="457200" y="2423160"/>
+            <a:ext cx="228600" cy="228600"/>
+          </a:xfrm>
+          <a:prstGeom prst="rect">
+            <a:avLst/>
+          </a:prstGeom>
+          <a:solidFill>
+            <a:srgbClr val="C0392B"/>
+          </a:solidFill>
+          <a:ln>
+            <a:noFill/>
+          </a:ln>
+        </p:spPr>
+        <p:style>
+          <a:lnRef idx="1">
+            <a:schemeClr val="accent1"/>
+          </a:lnRef>
+          <a:fillRef idx="3">
+            <a:schemeClr val="accent1"/>
+          </a:fillRef>
+          <a:effectRef idx="2">
+            <a:schemeClr val="accent1"/>
+          </a:effectRef>
+          <a:fontRef idx="minor">
+            <a:schemeClr val="lt1"/>
+          </a:fontRef>
+        </p:style>
+        <p:txBody>
+          <a:bodyPr rtlCol="0" anchor="ctr"/>
+          <a:lstStyle/>
+          <a:p>
+            <a:pPr algn="ctr"/>
+          </a:p>
+        </p:txBody>
+      </p:sp>
+      <p:sp>
+        <p:nvSpPr>
+          <p:cNvPr id="9" name="TextBox 8"/>
+          <p:cNvSpPr txBox="1"/>
+          <p:nvPr/>
+        </p:nvSpPr>
+        <p:spPr>
+          <a:xfrm>
+            <a:off x="777240" y="2377440"/>
+            <a:ext cx="4572000" cy="320040"/>
+          </a:xfrm>
+          <a:prstGeom prst="rect">
+            <a:avLst/>
+          </a:prstGeom>
+          <a:noFill/>
+        </p:spPr>
+        <p:txBody>
+          <a:bodyPr wrap="square">
+            <a:spAutoFit/>
+          </a:bodyPr>
+          <a:lstStyle/>
+          <a:p>
+            <a:pPr algn="l"/>
+            <a:r>
+              <a:rPr sz="1400" b="0">
+                <a:solidFill>
+                  <a:srgbClr val="1A2E4A"/>
+                </a:solidFill>
+              </a:rPr>
+              <a:t>TV/CTV commands 37% of media budget ($5.6M) with only 2.34 ROAS and no incrementality validation — there is a material risk that a significant portion of this spend is capturing organic or search-driven demand rather than creating it.</a:t>
+            </a:r>
+          </a:p>
+        </p:txBody>
+      </p:sp>
+      <p:sp>
+        <p:nvSpPr>
+          <p:cNvPr id="10" name="TextBox 9"/>
+          <p:cNvSpPr txBox="1"/>
+          <p:nvPr/>
+        </p:nvSpPr>
+        <p:spPr>
+          <a:xfrm>
+            <a:off x="777240" y="2697480"/>
+            <a:ext cx="4572000" cy="320040"/>
+          </a:xfrm>
+          <a:prstGeom prst="rect">
+            <a:avLst/>
+          </a:prstGeom>
+          <a:noFill/>
+        </p:spPr>
+        <p:txBody>
+          <a:bodyPr wrap="square">
+            <a:spAutoFit/>
+          </a:bodyPr>
+          <a:lstStyle/>
+          <a:p>
+            <a:pPr algn="l"/>
+            <a:r>
+              <a:rPr sz="1200" b="0">
+                <a:solidFill>
+                  <a:srgbClr val="6B7A90"/>
+                </a:solidFill>
+              </a:rPr>
+              <a:t>Action: Commission a geo-holdout or incrementality test on TV/CTV within this quarter. If true incremental ROAS falls below 1.5, reallocate $1-2M to proven digital performers.</a:t>
+            </a:r>
+          </a:p>
+        </p:txBody>
+      </p:sp>
+      <p:sp>
+        <p:nvSpPr>
+          <p:cNvPr id="11" name="Rectangle 10"/>
+          <p:cNvSpPr/>
+          <p:nvPr/>
+        </p:nvSpPr>
+        <p:spPr>
+          <a:xfrm>
+            <a:off x="457200" y="3200400"/>
+            <a:ext cx="228600" cy="228600"/>
+          </a:xfrm>
+          <a:prstGeom prst="rect">
+            <a:avLst/>
+          </a:prstGeom>
+          <a:solidFill>
+            <a:srgbClr val="E67E22"/>
+          </a:solidFill>
+          <a:ln>
+            <a:noFill/>
+          </a:ln>
+        </p:spPr>
+        <p:style>
+          <a:lnRef idx="1">
+            <a:schemeClr val="accent1"/>
+          </a:lnRef>
+          <a:fillRef idx="3">
+            <a:schemeClr val="accent1"/>
+          </a:fillRef>
+          <a:effectRef idx="2">
+            <a:schemeClr val="accent1"/>
+          </a:effectRef>
+          <a:fontRef idx="minor">
+            <a:schemeClr val="lt1"/>
+          </a:fontRef>
+        </p:style>
+        <p:txBody>
+          <a:bodyPr rtlCol="0" anchor="ctr"/>
+          <a:lstStyle/>
+          <a:p>
+            <a:pPr algn="ctr"/>
+          </a:p>
+        </p:txBody>
+      </p:sp>
+      <p:sp>
+        <p:nvSpPr>
+          <p:cNvPr id="12" name="TextBox 11"/>
+          <p:cNvSpPr txBox="1"/>
+          <p:nvPr/>
+        </p:nvSpPr>
+        <p:spPr>
+          <a:xfrm>
+            <a:off x="777240" y="3154680"/>
+            <a:ext cx="4572000" cy="320040"/>
+          </a:xfrm>
+          <a:prstGeom prst="rect">
+            <a:avLst/>
+          </a:prstGeom>
+          <a:noFill/>
+        </p:spPr>
+        <p:txBody>
+          <a:bodyPr wrap="square">
+            <a:spAutoFit/>
+          </a:bodyPr>
+          <a:lstStyle/>
+          <a:p>
+            <a:pPr algn="l"/>
+            <a:r>
+              <a:rPr sz="1400" b="0">
+                <a:solidFill>
+                  <a:srgbClr val="1A2E4A"/>
+                </a:solidFill>
+              </a:rPr>
+              <a:t>Over-reliance on Northeast region (27.4% of offline revenue). Any regional disruption — retailer delistings, competitive entry, weather events — disproportionately impacts total offline performance.</a:t>
+            </a:r>
+          </a:p>
+        </p:txBody>
+      </p:sp>
+      <p:sp>
+        <p:nvSpPr>
+          <p:cNvPr id="13" name="TextBox 12"/>
+          <p:cNvSpPr txBox="1"/>
+          <p:nvPr/>
+        </p:nvSpPr>
+        <p:spPr>
+          <a:xfrm>
+            <a:off x="777240" y="3474720"/>
+            <a:ext cx="4572000" cy="320040"/>
+          </a:xfrm>
+          <a:prstGeom prst="rect">
+            <a:avLst/>
+          </a:prstGeom>
+          <a:noFill/>
+        </p:spPr>
+        <p:txBody>
+          <a:bodyPr wrap="square">
+            <a:spAutoFit/>
+          </a:bodyPr>
+          <a:lstStyle/>
+          <a:p>
+            <a:pPr algn="l"/>
+            <a:r>
+              <a:rPr sz="1200" b="0">
+                <a:solidFill>
+                  <a:srgbClr val="6B7A90"/>
+                </a:solidFill>
+              </a:rPr>
+              <a:t>Action: Develop a Southwest and West growth plan targeting the $5-6M gap to Northeast, with regional trade promotions and expanded distribution within 90 days.</a:t>
+            </a:r>
+          </a:p>
+        </p:txBody>
+      </p:sp>
+      <p:sp>
+        <p:nvSpPr>
+          <p:cNvPr id="14" name="TextBox 13"/>
+          <p:cNvSpPr txBox="1"/>
+          <p:nvPr/>
+        </p:nvSpPr>
+        <p:spPr>
+          <a:xfrm>
+            <a:off x="6400800" y="1188720"/>
+            <a:ext cx="5029200" cy="365760"/>
+          </a:xfrm>
+          <a:prstGeom prst="rect">
+            <a:avLst/>
+          </a:prstGeom>
+          <a:noFill/>
+        </p:spPr>
+        <p:txBody>
+          <a:bodyPr wrap="square">
+            <a:spAutoFit/>
+          </a:bodyPr>
+          <a:lstStyle/>
+          <a:p>
+            <a:pPr algn="l"/>
+            <a:r>
+              <a:rPr sz="1600" b="1">
+                <a:solidFill>
+                  <a:srgbClr val="27AE60"/>
+                </a:solidFill>
+              </a:rPr>
+              <a:t>Opportunities</a:t>
+            </a:r>
+          </a:p>
+        </p:txBody>
+      </p:sp>
+      <p:sp>
+        <p:nvSpPr>
+          <p:cNvPr id="15" name="Rectangle 14"/>
+          <p:cNvSpPr/>
+          <p:nvPr/>
+        </p:nvSpPr>
+        <p:spPr>
+          <a:xfrm>
+            <a:off x="6400800" y="1645920"/>
+            <a:ext cx="228600" cy="228600"/>
+          </a:xfrm>
+          <a:prstGeom prst="rect">
+            <a:avLst/>
+          </a:prstGeom>
+          <a:solidFill>
+            <a:srgbClr val="27AE60"/>
+          </a:solidFill>
+          <a:ln>
+            <a:noFill/>
+          </a:ln>
+        </p:spPr>
+        <p:style>
+          <a:lnRef idx="1">
+            <a:schemeClr val="accent1"/>
+          </a:lnRef>
+          <a:fillRef idx="3">
+            <a:schemeClr val="accent1"/>
+          </a:fillRef>
+          <a:effectRef idx="2">
+            <a:schemeClr val="accent1"/>
+          </a:effectRef>
+          <a:fontRef idx="minor">
+            <a:schemeClr val="lt1"/>
+          </a:fontRef>
+        </p:style>
+        <p:txBody>
+          <a:bodyPr rtlCol="0" anchor="ctr"/>
+          <a:lstStyle/>
+          <a:p>
+            <a:pPr algn="ctr"/>
+          </a:p>
+        </p:txBody>
+      </p:sp>
+      <p:sp>
+        <p:nvSpPr>
+          <p:cNvPr id="16" name="TextBox 15"/>
+          <p:cNvSpPr txBox="1"/>
+          <p:nvPr/>
+        </p:nvSpPr>
+        <p:spPr>
+          <a:xfrm>
+            <a:off x="6720840" y="1600200"/>
+            <a:ext cx="5029200" cy="320040"/>
+          </a:xfrm>
+          <a:prstGeom prst="rect">
+            <a:avLst/>
+          </a:prstGeom>
+          <a:noFill/>
+        </p:spPr>
+        <p:txBody>
+          <a:bodyPr wrap="square">
+            <a:spAutoFit/>
+          </a:bodyPr>
+          <a:lstStyle/>
+          <a:p>
+            <a:pPr algn="l"/>
+            <a:r>
+              <a:rPr sz="1400" b="0">
+                <a:solidFill>
+                  <a:srgbClr val="1A2E4A"/>
+                </a:solidFill>
+              </a:rPr>
+              <a:t>Scale Email channel from $527K to $1M+ — it is delivering 6.39 ROAS and is the most underfunded channel by a wide margin. Every additional dollar here works nearly 3x harder than the blended average.</a:t>
+            </a:r>
+          </a:p>
+        </p:txBody>
+      </p:sp>
+      <p:sp>
+        <p:nvSpPr>
+          <p:cNvPr id="17" name="TextBox 16"/>
+          <p:cNvSpPr txBox="1"/>
+          <p:nvPr/>
+        </p:nvSpPr>
+        <p:spPr>
+          <a:xfrm>
+            <a:off x="6720840" y="1920240"/>
+            <a:ext cx="5029200" cy="320040"/>
+          </a:xfrm>
+          <a:prstGeom prst="rect">
+            <a:avLst/>
+          </a:prstGeom>
+          <a:noFill/>
+        </p:spPr>
+        <p:txBody>
+          <a:bodyPr wrap="square">
+            <a:spAutoFit/>
+          </a:bodyPr>
+          <a:lstStyle/>
+          <a:p>
+            <a:pPr algn="l"/>
+            <a:r>
+              <a:rPr sz="1200" b="0">
+                <a:solidFill>
+                  <a:srgbClr val="6B7A90"/>
+                </a:solidFill>
+              </a:rPr>
+              <a:t>Impact: $2.0-3.0M incremental revenue on $500K additional spend  |  30 days</a:t>
+            </a:r>
+          </a:p>
+        </p:txBody>
+      </p:sp>
+      <p:sp>
+        <p:nvSpPr>
+          <p:cNvPr id="18" name="Rectangle 17"/>
+          <p:cNvSpPr/>
+          <p:nvPr/>
+        </p:nvSpPr>
+        <p:spPr>
+          <a:xfrm>
+            <a:off x="6400800" y="2423160"/>
+            <a:ext cx="228600" cy="228600"/>
+          </a:xfrm>
+          <a:prstGeom prst="rect">
+            <a:avLst/>
+          </a:prstGeom>
+          <a:solidFill>
+            <a:srgbClr val="27AE60"/>
+          </a:solidFill>
+          <a:ln>
+            <a:noFill/>
+          </a:ln>
+        </p:spPr>
+        <p:style>
+          <a:lnRef idx="1">
+            <a:schemeClr val="accent1"/>
+          </a:lnRef>
+          <a:fillRef idx="3">
+            <a:schemeClr val="accent1"/>
+          </a:fillRef>
+          <a:effectRef idx="2">
+            <a:schemeClr val="accent1"/>
+          </a:effectRef>
+          <a:fontRef idx="minor">
+            <a:schemeClr val="lt1"/>
+          </a:fontRef>
+        </p:style>
+        <p:txBody>
+          <a:bodyPr rtlCol="0" anchor="ctr"/>
+          <a:lstStyle/>
+          <a:p>
+            <a:pPr algn="ctr"/>
+          </a:p>
+        </p:txBody>
+      </p:sp>
+      <p:sp>
+        <p:nvSpPr>
+          <p:cNvPr id="19" name="TextBox 18"/>
+          <p:cNvSpPr txBox="1"/>
+          <p:nvPr/>
+        </p:nvSpPr>
+        <p:spPr>
+          <a:xfrm>
+            <a:off x="6720840" y="2377440"/>
+            <a:ext cx="5029200" cy="320040"/>
+          </a:xfrm>
+          <a:prstGeom prst="rect">
+            <a:avLst/>
+          </a:prstGeom>
+          <a:noFill/>
+        </p:spPr>
+        <p:txBody>
+          <a:bodyPr wrap="square">
+            <a:spAutoFit/>
+          </a:bodyPr>
+          <a:lstStyle/>
+          <a:p>
+            <a:pPr algn="l"/>
+            <a:r>
+              <a:rPr sz="1400" b="0">
+                <a:solidFill>
+                  <a:srgbClr val="1A2E4A"/>
+                </a:solidFill>
+              </a:rPr>
+              <a:t>Fix funnel conversion from 2.62% to 4.0% through lead scoring, mid-funnel nurture automation, and sales process optimization. On the existing 25K lead base, this adds ~345 incremental deals.</a:t>
+            </a:r>
+          </a:p>
+        </p:txBody>
+      </p:sp>
+      <p:sp>
+        <p:nvSpPr>
+          <p:cNvPr id="20" name="TextBox 19"/>
+          <p:cNvSpPr txBox="1"/>
+          <p:nvPr/>
+        </p:nvSpPr>
+        <p:spPr>
+          <a:xfrm>
+            <a:off x="6720840" y="2697480"/>
+            <a:ext cx="5029200" cy="320040"/>
+          </a:xfrm>
+          <a:prstGeom prst="rect">
+            <a:avLst/>
+          </a:prstGeom>
+          <a:noFill/>
+        </p:spPr>
+        <p:txBody>
+          <a:bodyPr wrap="square">
+            <a:spAutoFit/>
+          </a:bodyPr>
+          <a:lstStyle/>
+          <a:p>
+            <a:pPr algn="l"/>
+            <a:r>
+              <a:rPr sz="1200" b="0">
+                <a:solidFill>
+                  <a:srgbClr val="6B7A90"/>
+                </a:solidFill>
+              </a:rPr>
+              <a:t>Impact: $16.6M in additional closed-won pipeline (345 deals × $48K average deal value)  |  60-90 days</a:t>
+            </a:r>
+          </a:p>
+        </p:txBody>
+      </p:sp>
+      <p:sp>
+        <p:nvSpPr>
+          <p:cNvPr id="21" name="Rectangle 20"/>
+          <p:cNvSpPr/>
+          <p:nvPr/>
+        </p:nvSpPr>
+        <p:spPr>
+          <a:xfrm>
+            <a:off x="6400800" y="3200400"/>
+            <a:ext cx="228600" cy="228600"/>
+          </a:xfrm>
+          <a:prstGeom prst="rect">
+            <a:avLst/>
+          </a:prstGeom>
+          <a:solidFill>
+            <a:srgbClr val="27AE60"/>
+          </a:solidFill>
+          <a:ln>
+            <a:noFill/>
+          </a:ln>
+        </p:spPr>
+        <p:style>
+          <a:lnRef idx="1">
+            <a:schemeClr val="accent1"/>
+          </a:lnRef>
+          <a:fillRef idx="3">
+            <a:schemeClr val="accent1"/>
+          </a:fillRef>
+          <a:effectRef idx="2">
+            <a:schemeClr val="accent1"/>
+          </a:effectRef>
+          <a:fontRef idx="minor">
+            <a:schemeClr val="lt1"/>
+          </a:fontRef>
+        </p:style>
+        <p:txBody>
+          <a:bodyPr rtlCol="0" anchor="ctr"/>
+          <a:lstStyle/>
+          <a:p>
+            <a:pPr algn="ctr"/>
+          </a:p>
+        </p:txBody>
+      </p:sp>
+      <p:sp>
+        <p:nvSpPr>
+          <p:cNvPr id="22" name="TextBox 21"/>
+          <p:cNvSpPr txBox="1"/>
+          <p:nvPr/>
+        </p:nvSpPr>
+        <p:spPr>
+          <a:xfrm>
+            <a:off x="6720840" y="3154680"/>
+            <a:ext cx="5029200" cy="320040"/>
+          </a:xfrm>
+          <a:prstGeom prst="rect">
+            <a:avLst/>
+          </a:prstGeom>
+          <a:noFill/>
+        </p:spPr>
+        <p:txBody>
+          <a:bodyPr wrap="square">
+            <a:spAutoFit/>
+          </a:bodyPr>
+          <a:lstStyle/>
+          <a:p>
+            <a:pPr algn="l"/>
+            <a:r>
+              <a:rPr sz="1400" b="0">
+                <a:solidFill>
+                  <a:srgbClr val="1A2E4A"/>
+                </a:solidFill>
+              </a:rPr>
+              <a:t>Launch a structured customer referral program to activate the weakest but highest-potential lead source. Referral leads convert at industry rates of 10-15%, vs. the current blended 2.62%.</a:t>
+            </a:r>
+          </a:p>
+        </p:txBody>
+      </p:sp>
+      <p:sp>
+        <p:nvSpPr>
+          <p:cNvPr id="23" name="TextBox 22"/>
+          <p:cNvSpPr txBox="1"/>
+          <p:nvPr/>
+        </p:nvSpPr>
+        <p:spPr>
+          <a:xfrm>
+            <a:off x="6720840" y="3474720"/>
+            <a:ext cx="5029200" cy="320040"/>
+          </a:xfrm>
+          <a:prstGeom prst="rect">
+            <a:avLst/>
+          </a:prstGeom>
+          <a:noFill/>
+        </p:spPr>
+        <p:txBody>
+          <a:bodyPr wrap="square">
+            <a:spAutoFit/>
+          </a:bodyPr>
+          <a:lstStyle/>
+          <a:p>
+            <a:pPr algn="l"/>
+            <a:r>
+              <a:rPr sz="1200" b="0">
+                <a:solidFill>
+                  <a:srgbClr val="6B7A90"/>
+                </a:solidFill>
+              </a:rPr>
+              <a:t>Impact: $5-8M in high-quality pipeline within 6 months if referral volume reaches 2,000+ leads  |  60 days to launch</a:t>
+            </a:r>
+          </a:p>
+        </p:txBody>
+      </p:sp>
+    </p:spTree>
+  </p:cSld>
+  <p:clrMapOvr>
+    <a:masterClrMapping/>
+  </p:clrMapOvr>
+</p:sld>
+</file>
+
+<file path=ppt/slides/slide7.xml><?xml version="1.0" encoding="utf-8"?>
 <p:sld xmlns:a="http://schemas.openxmlformats.org/drawingml/2006/main" xmlns:p="http://schemas.openxmlformats.org/presentationml/2006/main" xmlns:r="http://schemas.openxmlformats.org/officeDocument/2006/relationships">
   <p:cSld>
     <p:bg>

</xml_diff>